<commit_message>
docs: record public H5AD demo and update technical deck
</commit_message>
<xml_diff>
--- a/docs/technical-deck/Celloras-Technical-Deck.pptx
+++ b/docs/technical-deck/Celloras-Technical-Deck.pptx
@@ -2,21 +2,21 @@
 <file path=ppt/presentation.xml><?xml version="1.0" encoding="utf-8"?>
 <p:presentation xmlns:p="http://schemas.openxmlformats.org/presentationml/2006/main">
   <p:sldMasterIdLst>
-    <p:sldMasterId xmlns:r="http://schemas.openxmlformats.org/officeDocument/2006/relationships" id="2147483648" r:id="R3f1d72144d964b19"/>
+    <p:sldMasterId xmlns:r="http://schemas.openxmlformats.org/officeDocument/2006/relationships" id="2147483648" r:id="R322cecabf34747a2"/>
   </p:sldMasterIdLst>
   <p:notesMasterIdLst>
-    <p:notesMasterId xmlns:r="http://schemas.openxmlformats.org/officeDocument/2006/relationships" r:id="R9ad6f49bd01944b8"/>
+    <p:notesMasterId xmlns:r="http://schemas.openxmlformats.org/officeDocument/2006/relationships" r:id="R456f493ba7df4c93"/>
   </p:notesMasterIdLst>
   <p:sldIdLst>
-    <p:sldId xmlns:r="http://schemas.openxmlformats.org/officeDocument/2006/relationships" id="256" r:id="R261f4d1d7ef64877"/>
-    <p:sldId xmlns:r="http://schemas.openxmlformats.org/officeDocument/2006/relationships" id="257" r:id="R9484c7801b664202"/>
-    <p:sldId xmlns:r="http://schemas.openxmlformats.org/officeDocument/2006/relationships" id="258" r:id="R451da34b835c42dd"/>
-    <p:sldId xmlns:r="http://schemas.openxmlformats.org/officeDocument/2006/relationships" id="259" r:id="R86eb15bb51bf406b"/>
-    <p:sldId xmlns:r="http://schemas.openxmlformats.org/officeDocument/2006/relationships" id="260" r:id="Rd42abf9233714b09"/>
-    <p:sldId xmlns:r="http://schemas.openxmlformats.org/officeDocument/2006/relationships" id="261" r:id="R2fed208860724028"/>
-    <p:sldId xmlns:r="http://schemas.openxmlformats.org/officeDocument/2006/relationships" id="262" r:id="R553658aab6424ace"/>
-    <p:sldId xmlns:r="http://schemas.openxmlformats.org/officeDocument/2006/relationships" id="263" r:id="R6a70172fef19438d"/>
-    <p:sldId xmlns:r="http://schemas.openxmlformats.org/officeDocument/2006/relationships" id="264" r:id="R75220c87b59f4ce9"/>
+    <p:sldId xmlns:r="http://schemas.openxmlformats.org/officeDocument/2006/relationships" id="256" r:id="Rb0f9405300e94537"/>
+    <p:sldId xmlns:r="http://schemas.openxmlformats.org/officeDocument/2006/relationships" id="257" r:id="Rad2852674d904561"/>
+    <p:sldId xmlns:r="http://schemas.openxmlformats.org/officeDocument/2006/relationships" id="258" r:id="R1150b92e97134187"/>
+    <p:sldId xmlns:r="http://schemas.openxmlformats.org/officeDocument/2006/relationships" id="259" r:id="Rff8f7f7f5d384024"/>
+    <p:sldId xmlns:r="http://schemas.openxmlformats.org/officeDocument/2006/relationships" id="260" r:id="Rc26fb9662b7e432b"/>
+    <p:sldId xmlns:r="http://schemas.openxmlformats.org/officeDocument/2006/relationships" id="261" r:id="R2c6d44ebe25940d7"/>
+    <p:sldId xmlns:r="http://schemas.openxmlformats.org/officeDocument/2006/relationships" id="262" r:id="R818b7afefb214d96"/>
+    <p:sldId xmlns:r="http://schemas.openxmlformats.org/officeDocument/2006/relationships" id="263" r:id="R476754368d4b4b3b"/>
+    <p:sldId xmlns:r="http://schemas.openxmlformats.org/officeDocument/2006/relationships" id="264" r:id="R05f2245699b64dcc"/>
   </p:sldIdLst>
   <p:sldSz cx="12192000" cy="6858000"/>
   <p:notesSz cx="6858000" cy="9144000"/>
@@ -645,7 +645,7 @@
           <a:lstStyle xmlns:a="http://schemas.openxmlformats.org/drawingml/2006/main"/>
           <a:p xmlns:a="http://schemas.openxmlformats.org/drawingml/2006/main">
             <a:r>
-              <a:t>This separates measured data, marker associations, literature context and researcher interpretation. GSE270392 and soybean-atlas.com describe the same underlying published atlas and are not independent confirmation. The numeric panel includes associations originally supported by Arabidopsis orthology, with that provenance retained, but Celloras does not currently perform live ortholog mapping. The root/nodule paper is in the literature collection; its gene build is not automatically transferred to the Wm82v4 panel. Guide ingestion is abstract-only. SoyBase, broader nodule annotation and H5AD user uploads are planned/current implementation work, not active reference adapters. All count-matrix data stays numeric rather than being embedded as text.</a:t>
+              <a:t>This separates measured data, marker associations, literature context and researcher interpretation. GSE270392 and soybean-atlas.com describe the same underlying published atlas and are not independent confirmation. The numeric panel includes associations originally supported by Arabidopsis orthology, with that provenance retained, but Celloras does not currently perform live ortholog mapping. The root/nodule paper is in the literature collection; its gene build is not automatically transferred to the Wm82v4 panel. Guide ingestion is abstract-only. H5AD uploads now enter an owned inspection/import queue and retain the original counts and UMAP. The public uploaded-file workflow passed on 26 October. SoyBase and broader nodule annotation remain planned, not active reference adapters. All count-matrix data stays numeric rather than being embedded as text.</a:t>
             </a:r>
           </a:p>
           <a:p xmlns:a="http://schemas.openxmlformats.org/drawingml/2006/main">
@@ -1035,7 +1035,7 @@
           <a:lstStyle xmlns:a="http://schemas.openxmlformats.org/drawingml/2006/main"/>
           <a:p xmlns:a="http://schemas.openxmlformats.org/drawingml/2006/main">
             <a:r>
-              <a:t>Keycloak handles login and credentials. The app enforces ownership before project/data/model/memory operations. Agent output must satisfy a JSON schema; cards reference canonical owned records, never arbitrary model-written HTML or fabricated chart payloads. The worker limits scientific tools to four per turn and saves JSON activity events with run identifiers. Failed/cancelled turns cannot expose completed result endpoints. The count matrix stays in numeric files, not a vector database. Curated literature currently uses lexical search, while H-MEM uses its reference hashed-embedding retrieval only for explicit reviews. NeMo Files and an NVIDIA observability dashboard are not active.</a:t>
+              <a:t>Keycloak handles login and credentials. The app enforces ownership before project/data/model/memory operations. Agent output must satisfy a JSON schema; cards reference canonical owned records, never arbitrary model-written HTML or fabricated chart payloads. The worker limits scientific tools to four per turn and saves JSON activity events with run identifiers. Failed/cancelled turns cannot expose completed result endpoints. H5AD uploads use checksummed 8 MiB chunks, PostgreSQL queue state and a bounded Python importer. The imported bundle is immutable and private to the owned experiment; the app and agent mount it read-only. The count matrix stays in numeric files, not a vector database. Curated literature currently uses lexical search, while H-MEM uses its reference hashed-embedding retrieval only for explicit reviews. NeMo Files and an NVIDIA observability dashboard are not active.</a:t>
             </a:r>
           </a:p>
           <a:p xmlns:a="http://schemas.openxmlformats.org/drawingml/2006/main">
@@ -1140,7 +1140,7 @@
           <a:lstStyle xmlns:a="http://schemas.openxmlformats.org/drawingml/2006/main"/>
           <a:p xmlns:a="http://schemas.openxmlformats.org/drawingml/2006/main">
             <a:r>
-              <a:t>The points are copied from the user-provided judging screenshot: Demo 15, Product &amp; UX 10, Sponsor Tech 10. These are rubric weights, not awarded scores or an inferred complete rubric. The user supplied updated submission instructions requiring only Zetaris and a Meterless Engine in a working feature, with Cursor and NVIDIA optional. Celloras uses Zetaris, Meterless H-MEM and NVIDIA OpenShell. It does not claim Cursor usage, a working Nemotron call or an NVIDIA observability dashboard. Recorded public acceptance used the same project for annotation, real reference receipt, supporting gene plot, saved review and corrected recall. The current video is still to be recorded. The prepared workflow script resumes saved verified turns; replay is not a new benchmark or fresh inference for every step.</a:t>
+              <a:t>The points are copied from the user-provided judging screenshot: Demo 15, Product &amp; UX 10, Sponsor Tech 10. These are rubric weights, not awarded scores or an inferred complete rubric. The user supplied updated submission instructions requiring only Zetaris and a Meterless Engine in a working feature, with Cursor and NVIDIA optional. Celloras uses Zetaris, Meterless H-MEM and NVIDIA OpenShell. It does not claim Cursor usage, a working Nemotron call or an NVIDIA observability dashboard. The 26 October uploaded-file acceptance used the same project for H5AD upload, annotation, a real reference receipt, supporting gene plot, an illustrative saved review and H-MEM recall. The separate 25 October prepared workflow also proved correction recall. The current video is still to be recorded. The prepared workflow script resumes saved verified turns; replay is not a new benchmark or fresh inference for every step.</a:t>
             </a:r>
           </a:p>
           <a:p xmlns:a="http://schemas.openxmlformats.org/drawingml/2006/main">
@@ -1235,7 +1235,7 @@
           <a:lstStyle xmlns:a="http://schemas.openxmlformats.org/drawingml/2006/main"/>
           <a:p xmlns:a="http://schemas.openxmlformats.org/drawingml/2006/main">
             <a:r>
-              <a:t>Status at the technical-deck audit, 26 October 2026. H5AD implementation has started but was not verified or deployed when this deck was generated. Actual remote inspection of the author-published SOTA Root.scRNA.h5ad found 10,198 cells, 49,277 SoyZH13 genes, dense non-integer X, log1p metadata and no raw/count layers. It is unsuitable for our current raw-count/Wm82v4 workflow. The selected demo input is a transparent lossless H5AD conversion of the verified published GSE270392 root counts, groups and UMAP, retaining the original RDS SHA provenance. This is genuine published soybean data in a converted format, not an author-supplied H5AD. Existing functionality uses a pre-imported published dataset and small marker CSV lists. Raw FASTQ processing, arbitrary QC/batch correction/reclustering/new UMAP, automatic gene-build transfer and other plants are not demonstrated. The complete prepared public workflow passed, but broader local freeform tests have intermittent agent_execution_failed on the MicroVM runtime. Video recording, deck review and a final public smoke check remain before submission. Interface stubs for NeMo Files, Vercel gateway and NVIDIA tracing are not working integrations.</a:t>
+              <a:t>Public upload workflow accepted on 26 October 2026, source release e153cf8. The real browser downloaded the verified 28,919,346-byte sample, uploaded and inspected it, explicitly selected raw counts/groups/UMAP and imported all 7,496 nuclei and 40,127 genes. The OpenShell/Codex agent annotated the owned dataset, returned its 7,496-cell map, compared two measured genes, and recalled a saved illustrative review through Meterless H-MEM. Annotation run f21b6943-c980-454b-8870-643773341ae9 retains Zetaris request e37392b3-f96d-4ee6-82e9-73fe75b301a2. The sample is a transparent lossless H5AD conversion of the published GSE270392 root RDS, not an author-deposited H5AD or raw sequencing reads. Native SOTA Root.scRNA.h5ad has normalized noninteger values and SoyZH13 IDs and is unsuitable for this Wm82v4 raw-count workflow. Limits include existing groups/UMAP and compatible soybean-root reference identifiers; no FASTQ processing, QC, new clustering, new embedding, automatic cross-build mapping or independent biological accuracy benchmark is claimed. The 4 GiB upload ceiling has not been load-tested. Broader local MicroVM freeform tests have shown intermittent execution failures, separate from this passing public Linux workflow. The video remains to be recorded.</a:t>
             </a:r>
           </a:p>
           <a:p xmlns:a="http://schemas.openxmlformats.org/drawingml/2006/main">
@@ -1255,7 +1255,7 @@
           </a:p>
           <a:p xmlns:a="http://schemas.openxmlformats.org/drawingml/2006/main">
             <a:r>
-              <a:t>https://github.com/mpckkk/2026_GenAI/blob/celloras.com/docs/dataset-import.md</a:t>
+              <a:t>https://github.com/mpckkk/2026_GenAI/blob/celloras.com/docs/h5ad-source.md</a:t>
             </a:r>
           </a:p>
           <a:p xmlns:a="http://schemas.openxmlformats.org/drawingml/2006/main">
@@ -1265,7 +1265,7 @@
           </a:p>
           <a:p xmlns:a="http://schemas.openxmlformats.org/drawingml/2006/main">
             <a:r>
-              <a:t>https://db.cngb.org/stomics/soybean/download/</a:t>
+              <a:t>https://celloras.com/app/projects/fd21eefc-6a63-4c06-89fd-007ed138c77f</a:t>
             </a:r>
           </a:p>
         </p:txBody>
@@ -1312,7 +1312,7 @@
           <p:cNvPr id="3" name="Title">
             <a:extLst xmlns:a="http://schemas.openxmlformats.org/drawingml/2006/main">
               <a:ext uri="{FF2B5EF4-FFF2-40B4-BE49-F238E27FC236}">
-                <a16:creationId xmlns:a16="http://schemas.microsoft.com/office/drawing/2014/main" id="{9BAA1C82-18CB-4096-BF73-57FB738B9A88}"/>
+                <a16:creationId xmlns:a16="http://schemas.microsoft.com/office/drawing/2014/main" id="{2DB5B5F4-3A18-444A-9ED0-C923549FE9FE}"/>
               </a:ext>
             </a:extLst>
           </p:cNvPr>
@@ -1541,7 +1541,7 @@
           <p:cNvPr id="2" name="Subtitle">
             <a:extLst xmlns:a="http://schemas.openxmlformats.org/drawingml/2006/main">
               <a:ext uri="{FF2B5EF4-FFF2-40B4-BE49-F238E27FC236}">
-                <a16:creationId xmlns:a16="http://schemas.microsoft.com/office/drawing/2014/main" id="{0CAE7960-EE09-4D95-94B4-94F537C97E0F}"/>
+                <a16:creationId xmlns:a16="http://schemas.microsoft.com/office/drawing/2014/main" id="{57F2B1A1-E603-411F-827D-C656A904D5A7}"/>
               </a:ext>
             </a:extLst>
           </p:cNvPr>
@@ -1787,7 +1787,7 @@
           <p:cNvPr id="2" name="Section title">
             <a:extLst xmlns:a="http://schemas.openxmlformats.org/drawingml/2006/main">
               <a:ext uri="{FF2B5EF4-FFF2-40B4-BE49-F238E27FC236}">
-                <a16:creationId xmlns:a16="http://schemas.microsoft.com/office/drawing/2014/main" id="{91FD5EF3-555F-4334-9863-88D1631434CD}"/>
+                <a16:creationId xmlns:a16="http://schemas.microsoft.com/office/drawing/2014/main" id="{529D8781-CA77-4634-A040-5FFDC3801488}"/>
               </a:ext>
             </a:extLst>
           </p:cNvPr>
@@ -2033,7 +2033,7 @@
           <p:cNvPr id="3" name="Title">
             <a:extLst xmlns:a="http://schemas.openxmlformats.org/drawingml/2006/main">
               <a:ext uri="{FF2B5EF4-FFF2-40B4-BE49-F238E27FC236}">
-                <a16:creationId xmlns:a16="http://schemas.microsoft.com/office/drawing/2014/main" id="{E15DC5FE-7954-4335-8197-22BF0FD14CC1}"/>
+                <a16:creationId xmlns:a16="http://schemas.microsoft.com/office/drawing/2014/main" id="{12959A06-F808-4468-9357-C13338B34DA7}"/>
               </a:ext>
             </a:extLst>
           </p:cNvPr>
@@ -2262,7 +2262,7 @@
           <p:cNvPr id="2" name="Body">
             <a:extLst xmlns:a="http://schemas.openxmlformats.org/drawingml/2006/main">
               <a:ext uri="{FF2B5EF4-FFF2-40B4-BE49-F238E27FC236}">
-                <a16:creationId xmlns:a16="http://schemas.microsoft.com/office/drawing/2014/main" id="{40F7B1ED-6DF8-439E-B133-23B8F911F87B}"/>
+                <a16:creationId xmlns:a16="http://schemas.microsoft.com/office/drawing/2014/main" id="{34ADD1EE-689C-4D0E-9ABE-B52678FEFC7D}"/>
               </a:ext>
             </a:extLst>
           </p:cNvPr>
@@ -2508,7 +2508,7 @@
           <p:cNvPr id="4" name="Title">
             <a:extLst xmlns:a="http://schemas.openxmlformats.org/drawingml/2006/main">
               <a:ext uri="{FF2B5EF4-FFF2-40B4-BE49-F238E27FC236}">
-                <a16:creationId xmlns:a16="http://schemas.microsoft.com/office/drawing/2014/main" id="{1F7ECBE3-64EC-4E01-BB67-142D5ECEB69D}"/>
+                <a16:creationId xmlns:a16="http://schemas.microsoft.com/office/drawing/2014/main" id="{FA551A0A-8F95-4592-A270-35EB75EDC6D7}"/>
               </a:ext>
             </a:extLst>
           </p:cNvPr>
@@ -2737,7 +2737,7 @@
           <p:cNvPr id="2" name="Left column">
             <a:extLst xmlns:a="http://schemas.openxmlformats.org/drawingml/2006/main">
               <a:ext uri="{FF2B5EF4-FFF2-40B4-BE49-F238E27FC236}">
-                <a16:creationId xmlns:a16="http://schemas.microsoft.com/office/drawing/2014/main" id="{8E001964-801A-4415-90E2-46885470D2D7}"/>
+                <a16:creationId xmlns:a16="http://schemas.microsoft.com/office/drawing/2014/main" id="{F2529F10-CBA6-4A7D-AFA0-047100A91368}"/>
               </a:ext>
             </a:extLst>
           </p:cNvPr>
@@ -2966,7 +2966,7 @@
           <p:cNvPr id="3" name="Right column">
             <a:extLst xmlns:a="http://schemas.openxmlformats.org/drawingml/2006/main">
               <a:ext uri="{FF2B5EF4-FFF2-40B4-BE49-F238E27FC236}">
-                <a16:creationId xmlns:a16="http://schemas.microsoft.com/office/drawing/2014/main" id="{1BA7FC67-1A47-49A0-8B8E-24A04C19350C}"/>
+                <a16:creationId xmlns:a16="http://schemas.microsoft.com/office/drawing/2014/main" id="{38D40DB3-7514-4353-B24D-59BF6E12B401}"/>
               </a:ext>
             </a:extLst>
           </p:cNvPr>
@@ -3212,7 +3212,7 @@
           <p:cNvPr id="3" name="Title">
             <a:extLst xmlns:a="http://schemas.openxmlformats.org/drawingml/2006/main">
               <a:ext uri="{FF2B5EF4-FFF2-40B4-BE49-F238E27FC236}">
-                <a16:creationId xmlns:a16="http://schemas.microsoft.com/office/drawing/2014/main" id="{0B784BA7-FC35-41B6-9CD0-D43AF7B9667F}"/>
+                <a16:creationId xmlns:a16="http://schemas.microsoft.com/office/drawing/2014/main" id="{D03DB455-8B3A-4923-A848-F19C1B84E244}"/>
               </a:ext>
             </a:extLst>
           </p:cNvPr>
@@ -3441,7 +3441,7 @@
           <p:cNvPr id="2" name="Left column">
             <a:extLst xmlns:a="http://schemas.openxmlformats.org/drawingml/2006/main">
               <a:ext uri="{FF2B5EF4-FFF2-40B4-BE49-F238E27FC236}">
-                <a16:creationId xmlns:a16="http://schemas.microsoft.com/office/drawing/2014/main" id="{4FF945EF-D614-43BE-88E3-44135613C353}"/>
+                <a16:creationId xmlns:a16="http://schemas.microsoft.com/office/drawing/2014/main" id="{5135F7F5-4E56-4C42-8BEE-7A20935CC2A9}"/>
               </a:ext>
             </a:extLst>
           </p:cNvPr>
@@ -3708,12 +3708,12 @@
   </p:cSld>
   <p:clrMap bg1="lt1" tx1="dk1" bg2="lt2" tx2="dk2" accent1="accent1" accent2="accent2" accent3="accent3" accent4="accent4" accent5="accent5" accent6="accent6" hlink="hlink" folHlink="folHlink"/>
   <p:sldLayoutIdLst>
-    <p:sldLayoutId xmlns:r="http://schemas.openxmlformats.org/officeDocument/2006/relationships" id="2147483649" r:id="Rbd1235595bd94c1d"/>
-    <p:sldLayoutId xmlns:r="http://schemas.openxmlformats.org/officeDocument/2006/relationships" id="2147483650" r:id="R98aef2ec36854b78"/>
-    <p:sldLayoutId xmlns:r="http://schemas.openxmlformats.org/officeDocument/2006/relationships" id="2147483651" r:id="Re38c0e1b33c24a40"/>
-    <p:sldLayoutId xmlns:r="http://schemas.openxmlformats.org/officeDocument/2006/relationships" id="2147483652" r:id="R546dec5216544ee6"/>
-    <p:sldLayoutId xmlns:r="http://schemas.openxmlformats.org/officeDocument/2006/relationships" id="2147483653" r:id="Rd648bf2a067f4632"/>
-    <p:sldLayoutId xmlns:r="http://schemas.openxmlformats.org/officeDocument/2006/relationships" id="2147483654" r:id="R88c1ec68535a4254"/>
+    <p:sldLayoutId xmlns:r="http://schemas.openxmlformats.org/officeDocument/2006/relationships" id="2147483649" r:id="R15d95d88e4794a16"/>
+    <p:sldLayoutId xmlns:r="http://schemas.openxmlformats.org/officeDocument/2006/relationships" id="2147483650" r:id="Rd64eb4163c1940fd"/>
+    <p:sldLayoutId xmlns:r="http://schemas.openxmlformats.org/officeDocument/2006/relationships" id="2147483651" r:id="Rfb443a0035b24960"/>
+    <p:sldLayoutId xmlns:r="http://schemas.openxmlformats.org/officeDocument/2006/relationships" id="2147483652" r:id="Rc0127b9e3f734c3b"/>
+    <p:sldLayoutId xmlns:r="http://schemas.openxmlformats.org/officeDocument/2006/relationships" id="2147483653" r:id="R1f4833f177064b9e"/>
+    <p:sldLayoutId xmlns:r="http://schemas.openxmlformats.org/officeDocument/2006/relationships" id="2147483654" r:id="Rf9ca7aca3c824b6e"/>
   </p:sldLayoutIdLst>
   <p:txStyles>
     <p:titleStyle>
@@ -4264,7 +4264,7 @@
           <p:cNvPr id="28" name="">
             <a:extLst xmlns:a="http://schemas.openxmlformats.org/drawingml/2006/main">
               <a:ext uri="{FF2B5EF4-FFF2-40B4-BE49-F238E27FC236}">
-                <a16:creationId xmlns:a16="http://schemas.microsoft.com/office/drawing/2014/main" id="{AC770013-40C3-486C-B832-7C8C9356B738}"/>
+                <a16:creationId xmlns:a16="http://schemas.microsoft.com/office/drawing/2014/main" id="{6D8F5982-F3DD-48A0-A181-3EC4BF77CA57}"/>
               </a:ext>
             </a:extLst>
           </p:cNvPr>
@@ -4295,7 +4295,7 @@
           <p:cNvPr id="34" name="text-1">
             <a:extLst xmlns:a="http://schemas.openxmlformats.org/drawingml/2006/main">
               <a:ext uri="{FF2B5EF4-FFF2-40B4-BE49-F238E27FC236}">
-                <a16:creationId xmlns:a16="http://schemas.microsoft.com/office/drawing/2014/main" id="{FDF8944E-E115-4A8C-BA1D-5F7B81F40051}"/>
+                <a16:creationId xmlns:a16="http://schemas.microsoft.com/office/drawing/2014/main" id="{968311FE-AA88-4E7F-AD33-00F7589B7D56}"/>
               </a:ext>
             </a:extLst>
           </p:cNvPr>
@@ -4453,7 +4453,7 @@
           <p:cNvPr id="2" name="text-2">
             <a:extLst xmlns:a="http://schemas.openxmlformats.org/drawingml/2006/main">
               <a:ext uri="{FF2B5EF4-FFF2-40B4-BE49-F238E27FC236}">
-                <a16:creationId xmlns:a16="http://schemas.microsoft.com/office/drawing/2014/main" id="{99D7DD36-B9F0-4C6F-A50F-FFC32895AD33}"/>
+                <a16:creationId xmlns:a16="http://schemas.microsoft.com/office/drawing/2014/main" id="{EF7140B7-6ACF-4F3F-B1CC-524E5F5F3E10}"/>
               </a:ext>
             </a:extLst>
           </p:cNvPr>
@@ -4611,7 +4611,7 @@
           <p:cNvPr id="3" name="text-3">
             <a:extLst xmlns:a="http://schemas.openxmlformats.org/drawingml/2006/main">
               <a:ext uri="{FF2B5EF4-FFF2-40B4-BE49-F238E27FC236}">
-                <a16:creationId xmlns:a16="http://schemas.microsoft.com/office/drawing/2014/main" id="{20BA1543-3DB0-4EFA-B180-8B30BF0DCD77}"/>
+                <a16:creationId xmlns:a16="http://schemas.microsoft.com/office/drawing/2014/main" id="{97B2D6CD-E48F-4393-AC36-9C2B29EEBC92}"/>
               </a:ext>
             </a:extLst>
           </p:cNvPr>
@@ -4769,7 +4769,7 @@
           <p:cNvPr id="4" name="text-4">
             <a:extLst xmlns:a="http://schemas.openxmlformats.org/drawingml/2006/main">
               <a:ext uri="{FF2B5EF4-FFF2-40B4-BE49-F238E27FC236}">
-                <a16:creationId xmlns:a16="http://schemas.microsoft.com/office/drawing/2014/main" id="{EC0FC3A5-9119-43BE-B7C7-D2C304363697}"/>
+                <a16:creationId xmlns:a16="http://schemas.microsoft.com/office/drawing/2014/main" id="{C4D49CCD-C6E5-498D-B9D0-1BC0E5D70055}"/>
               </a:ext>
             </a:extLst>
           </p:cNvPr>
@@ -4927,7 +4927,7 @@
           <p:cNvPr id="5" name="box-5">
             <a:extLst xmlns:a="http://schemas.openxmlformats.org/drawingml/2006/main">
               <a:ext uri="{FF2B5EF4-FFF2-40B4-BE49-F238E27FC236}">
-                <a16:creationId xmlns:a16="http://schemas.microsoft.com/office/drawing/2014/main" id="{EAFB9140-8257-442F-8550-182287B9409A}"/>
+                <a16:creationId xmlns:a16="http://schemas.microsoft.com/office/drawing/2014/main" id="{26C31C80-C207-4252-B8C3-A78621E12B8E}"/>
               </a:ext>
             </a:extLst>
           </p:cNvPr>
@@ -4957,7 +4957,7 @@
           <p:cNvPr id="6" name="text-6">
             <a:extLst xmlns:a="http://schemas.openxmlformats.org/drawingml/2006/main">
               <a:ext uri="{FF2B5EF4-FFF2-40B4-BE49-F238E27FC236}">
-                <a16:creationId xmlns:a16="http://schemas.microsoft.com/office/drawing/2014/main" id="{C8A1F688-2DDB-4C1E-9D45-47DA35BC9EC4}"/>
+                <a16:creationId xmlns:a16="http://schemas.microsoft.com/office/drawing/2014/main" id="{63EA4D3B-0F0B-4A75-AA4F-A5CFCB71DDD9}"/>
               </a:ext>
             </a:extLst>
           </p:cNvPr>
@@ -5115,7 +5115,7 @@
           <p:cNvPr id="7" name="text-7">
             <a:extLst xmlns:a="http://schemas.openxmlformats.org/drawingml/2006/main">
               <a:ext uri="{FF2B5EF4-FFF2-40B4-BE49-F238E27FC236}">
-                <a16:creationId xmlns:a16="http://schemas.microsoft.com/office/drawing/2014/main" id="{F6FFB93B-942B-4C1C-84E8-E0AD8CF10692}"/>
+                <a16:creationId xmlns:a16="http://schemas.microsoft.com/office/drawing/2014/main" id="{44E5EBA6-F2E7-48DE-966C-EE49D70D0680}"/>
               </a:ext>
             </a:extLst>
           </p:cNvPr>
@@ -5273,7 +5273,7 @@
           <p:cNvPr id="8" name="box-8">
             <a:extLst xmlns:a="http://schemas.openxmlformats.org/drawingml/2006/main">
               <a:ext uri="{FF2B5EF4-FFF2-40B4-BE49-F238E27FC236}">
-                <a16:creationId xmlns:a16="http://schemas.microsoft.com/office/drawing/2014/main" id="{171D9932-0838-4D5B-BD4E-F96EAFB6A005}"/>
+                <a16:creationId xmlns:a16="http://schemas.microsoft.com/office/drawing/2014/main" id="{382E7CBA-6734-4568-B8F1-BF6360723598}"/>
               </a:ext>
             </a:extLst>
           </p:cNvPr>
@@ -5303,7 +5303,7 @@
           <p:cNvPr id="9" name="text-9">
             <a:extLst xmlns:a="http://schemas.openxmlformats.org/drawingml/2006/main">
               <a:ext uri="{FF2B5EF4-FFF2-40B4-BE49-F238E27FC236}">
-                <a16:creationId xmlns:a16="http://schemas.microsoft.com/office/drawing/2014/main" id="{C218D15E-FC0B-404F-BAD1-241DC371A05A}"/>
+                <a16:creationId xmlns:a16="http://schemas.microsoft.com/office/drawing/2014/main" id="{D06CE4E6-9420-49D2-8727-CD4E839B9EBF}"/>
               </a:ext>
             </a:extLst>
           </p:cNvPr>
@@ -5461,7 +5461,7 @@
           <p:cNvPr id="10" name="text-10">
             <a:extLst xmlns:a="http://schemas.openxmlformats.org/drawingml/2006/main">
               <a:ext uri="{FF2B5EF4-FFF2-40B4-BE49-F238E27FC236}">
-                <a16:creationId xmlns:a16="http://schemas.microsoft.com/office/drawing/2014/main" id="{49C73189-F631-4312-867D-935CEC2F0D87}"/>
+                <a16:creationId xmlns:a16="http://schemas.microsoft.com/office/drawing/2014/main" id="{B59CE2A2-B3BE-4D37-8EFB-CC035B6510D3}"/>
               </a:ext>
             </a:extLst>
           </p:cNvPr>
@@ -5619,7 +5619,7 @@
           <p:cNvPr id="11" name="box-11">
             <a:extLst xmlns:a="http://schemas.openxmlformats.org/drawingml/2006/main">
               <a:ext uri="{FF2B5EF4-FFF2-40B4-BE49-F238E27FC236}">
-                <a16:creationId xmlns:a16="http://schemas.microsoft.com/office/drawing/2014/main" id="{0A946955-3517-4BE7-8355-D9072DEED2FE}"/>
+                <a16:creationId xmlns:a16="http://schemas.microsoft.com/office/drawing/2014/main" id="{7B0F355B-31C6-4687-9102-5C44B327F4F3}"/>
               </a:ext>
             </a:extLst>
           </p:cNvPr>
@@ -5649,7 +5649,7 @@
           <p:cNvPr id="12" name="text-12">
             <a:extLst xmlns:a="http://schemas.openxmlformats.org/drawingml/2006/main">
               <a:ext uri="{FF2B5EF4-FFF2-40B4-BE49-F238E27FC236}">
-                <a16:creationId xmlns:a16="http://schemas.microsoft.com/office/drawing/2014/main" id="{714E0759-35F5-47C8-A5A7-6BC8CDAE9295}"/>
+                <a16:creationId xmlns:a16="http://schemas.microsoft.com/office/drawing/2014/main" id="{FF1360D9-32F1-45A2-9AA8-EC98ED894AD1}"/>
               </a:ext>
             </a:extLst>
           </p:cNvPr>
@@ -5807,7 +5807,7 @@
           <p:cNvPr id="13" name="text-13">
             <a:extLst xmlns:a="http://schemas.openxmlformats.org/drawingml/2006/main">
               <a:ext uri="{FF2B5EF4-FFF2-40B4-BE49-F238E27FC236}">
-                <a16:creationId xmlns:a16="http://schemas.microsoft.com/office/drawing/2014/main" id="{1235B45B-A766-4E33-93A0-47C70FC085FF}"/>
+                <a16:creationId xmlns:a16="http://schemas.microsoft.com/office/drawing/2014/main" id="{B0B5FD28-71A4-43C5-A5F1-4422C76FEAF7}"/>
               </a:ext>
             </a:extLst>
           </p:cNvPr>
@@ -5965,7 +5965,7 @@
           <p:cNvPr id="14" name="flow-14">
             <a:extLst xmlns:a="http://schemas.openxmlformats.org/drawingml/2006/main">
               <a:ext uri="{FF2B5EF4-FFF2-40B4-BE49-F238E27FC236}">
-                <a16:creationId xmlns:a16="http://schemas.microsoft.com/office/drawing/2014/main" id="{A770239B-388F-4224-95A2-9630C51F817D}"/>
+                <a16:creationId xmlns:a16="http://schemas.microsoft.com/office/drawing/2014/main" id="{B0006399-AE20-434A-B91C-EBBAE450509D}"/>
               </a:ext>
             </a:extLst>
           </p:cNvPr>
@@ -5995,7 +5995,7 @@
           <p:cNvPr id="15" name="flow-15">
             <a:extLst xmlns:a="http://schemas.openxmlformats.org/drawingml/2006/main">
               <a:ext uri="{FF2B5EF4-FFF2-40B4-BE49-F238E27FC236}">
-                <a16:creationId xmlns:a16="http://schemas.microsoft.com/office/drawing/2014/main" id="{4B5D7D0F-DEDA-4840-B523-612365461910}"/>
+                <a16:creationId xmlns:a16="http://schemas.microsoft.com/office/drawing/2014/main" id="{EEBAF2F4-F2F0-4023-9376-5301363CA6E8}"/>
               </a:ext>
             </a:extLst>
           </p:cNvPr>
@@ -6025,7 +6025,7 @@
           <p:cNvPr id="16" name="text-16">
             <a:extLst xmlns:a="http://schemas.openxmlformats.org/drawingml/2006/main">
               <a:ext uri="{FF2B5EF4-FFF2-40B4-BE49-F238E27FC236}">
-                <a16:creationId xmlns:a16="http://schemas.microsoft.com/office/drawing/2014/main" id="{8B40F387-00EC-4E0F-AEB4-33739070FBCD}"/>
+                <a16:creationId xmlns:a16="http://schemas.microsoft.com/office/drawing/2014/main" id="{71A8EA71-9E7E-4454-806A-B8EC8F2383CA}"/>
               </a:ext>
             </a:extLst>
           </p:cNvPr>
@@ -6183,7 +6183,7 @@
           <p:cNvPr id="17" name="text-17">
             <a:extLst xmlns:a="http://schemas.openxmlformats.org/drawingml/2006/main">
               <a:ext uri="{FF2B5EF4-FFF2-40B4-BE49-F238E27FC236}">
-                <a16:creationId xmlns:a16="http://schemas.microsoft.com/office/drawing/2014/main" id="{C1BCB9BD-3C25-414E-8BBC-909E3115EC52}"/>
+                <a16:creationId xmlns:a16="http://schemas.microsoft.com/office/drawing/2014/main" id="{B8808D42-A02A-4E9C-B8B6-451B8F8C7B38}"/>
               </a:ext>
             </a:extLst>
           </p:cNvPr>
@@ -6341,7 +6341,7 @@
           <p:cNvPr id="18" name="flow-18">
             <a:extLst xmlns:a="http://schemas.openxmlformats.org/drawingml/2006/main">
               <a:ext uri="{FF2B5EF4-FFF2-40B4-BE49-F238E27FC236}">
-                <a16:creationId xmlns:a16="http://schemas.microsoft.com/office/drawing/2014/main" id="{6D46EC22-D57B-494C-A250-4F4EC8B7082B}"/>
+                <a16:creationId xmlns:a16="http://schemas.microsoft.com/office/drawing/2014/main" id="{B2D6054F-A211-4835-9DA8-EADDCAD394EC}"/>
               </a:ext>
             </a:extLst>
           </p:cNvPr>
@@ -6371,7 +6371,7 @@
           <p:cNvPr id="19" name="box-19">
             <a:extLst xmlns:a="http://schemas.openxmlformats.org/drawingml/2006/main">
               <a:ext uri="{FF2B5EF4-FFF2-40B4-BE49-F238E27FC236}">
-                <a16:creationId xmlns:a16="http://schemas.microsoft.com/office/drawing/2014/main" id="{48B3E7FF-0DD6-42C2-BD1A-26F3BE3A097C}"/>
+                <a16:creationId xmlns:a16="http://schemas.microsoft.com/office/drawing/2014/main" id="{6D9C0965-CAD5-4150-8FF5-AE9F7C54D1F5}"/>
               </a:ext>
             </a:extLst>
           </p:cNvPr>
@@ -6401,7 +6401,7 @@
           <p:cNvPr id="20" name="text-20">
             <a:extLst xmlns:a="http://schemas.openxmlformats.org/drawingml/2006/main">
               <a:ext uri="{FF2B5EF4-FFF2-40B4-BE49-F238E27FC236}">
-                <a16:creationId xmlns:a16="http://schemas.microsoft.com/office/drawing/2014/main" id="{3C05ECA4-7EA8-465C-8496-1FB6C702B5A6}"/>
+                <a16:creationId xmlns:a16="http://schemas.microsoft.com/office/drawing/2014/main" id="{0E4E43D5-78AA-4165-BD8A-346367DB3A79}"/>
               </a:ext>
             </a:extLst>
           </p:cNvPr>
@@ -6559,7 +6559,7 @@
           <p:cNvPr id="21" name="text-21">
             <a:extLst xmlns:a="http://schemas.openxmlformats.org/drawingml/2006/main">
               <a:ext uri="{FF2B5EF4-FFF2-40B4-BE49-F238E27FC236}">
-                <a16:creationId xmlns:a16="http://schemas.microsoft.com/office/drawing/2014/main" id="{23969E6A-D9BA-4349-991D-450634189AAA}"/>
+                <a16:creationId xmlns:a16="http://schemas.microsoft.com/office/drawing/2014/main" id="{3D97BBA4-B281-43FE-87FE-DA60B78B1F3D}"/>
               </a:ext>
             </a:extLst>
           </p:cNvPr>
@@ -6740,7 +6740,7 @@
           <p:cNvPr id="22" name="box-22">
             <a:extLst xmlns:a="http://schemas.openxmlformats.org/drawingml/2006/main">
               <a:ext uri="{FF2B5EF4-FFF2-40B4-BE49-F238E27FC236}">
-                <a16:creationId xmlns:a16="http://schemas.microsoft.com/office/drawing/2014/main" id="{EAF1D21F-5DE2-4693-A5E1-94F85061D780}"/>
+                <a16:creationId xmlns:a16="http://schemas.microsoft.com/office/drawing/2014/main" id="{A183DD8B-281B-4615-B764-A4081DDC7881}"/>
               </a:ext>
             </a:extLst>
           </p:cNvPr>
@@ -6770,7 +6770,7 @@
           <p:cNvPr id="23" name="text-23">
             <a:extLst xmlns:a="http://schemas.openxmlformats.org/drawingml/2006/main">
               <a:ext uri="{FF2B5EF4-FFF2-40B4-BE49-F238E27FC236}">
-                <a16:creationId xmlns:a16="http://schemas.microsoft.com/office/drawing/2014/main" id="{ECF3EAE5-A0EB-4DC9-B18D-5E3319DD0446}"/>
+                <a16:creationId xmlns:a16="http://schemas.microsoft.com/office/drawing/2014/main" id="{312E5F99-75E2-422E-9BF2-28E4F5D3491A}"/>
               </a:ext>
             </a:extLst>
           </p:cNvPr>
@@ -6928,7 +6928,7 @@
           <p:cNvPr id="24" name="text-24">
             <a:extLst xmlns:a="http://schemas.openxmlformats.org/drawingml/2006/main">
               <a:ext uri="{FF2B5EF4-FFF2-40B4-BE49-F238E27FC236}">
-                <a16:creationId xmlns:a16="http://schemas.microsoft.com/office/drawing/2014/main" id="{B18F5B93-7BE9-4DCA-91D4-92C2B22F2F76}"/>
+                <a16:creationId xmlns:a16="http://schemas.microsoft.com/office/drawing/2014/main" id="{D97097DF-5700-4659-A4EE-8FDD2831DEF5}"/>
               </a:ext>
             </a:extLst>
           </p:cNvPr>
@@ -7109,7 +7109,7 @@
           <p:cNvPr id="25" name="box-25">
             <a:extLst xmlns:a="http://schemas.openxmlformats.org/drawingml/2006/main">
               <a:ext uri="{FF2B5EF4-FFF2-40B4-BE49-F238E27FC236}">
-                <a16:creationId xmlns:a16="http://schemas.microsoft.com/office/drawing/2014/main" id="{05D8E8CE-AB64-4728-894B-D8602E1248B4}"/>
+                <a16:creationId xmlns:a16="http://schemas.microsoft.com/office/drawing/2014/main" id="{8C6C4061-B011-4032-A7D7-EFE5DF7B8A11}"/>
               </a:ext>
             </a:extLst>
           </p:cNvPr>
@@ -7139,7 +7139,7 @@
           <p:cNvPr id="26" name="text-26">
             <a:extLst xmlns:a="http://schemas.openxmlformats.org/drawingml/2006/main">
               <a:ext uri="{FF2B5EF4-FFF2-40B4-BE49-F238E27FC236}">
-                <a16:creationId xmlns:a16="http://schemas.microsoft.com/office/drawing/2014/main" id="{BB8A8510-4747-459E-9518-041D975DE289}"/>
+                <a16:creationId xmlns:a16="http://schemas.microsoft.com/office/drawing/2014/main" id="{8DDEEBD0-D7DF-4FF0-B841-67DFA2E32ECB}"/>
               </a:ext>
             </a:extLst>
           </p:cNvPr>
@@ -7297,7 +7297,7 @@
           <p:cNvPr id="27" name="text-27">
             <a:extLst xmlns:a="http://schemas.openxmlformats.org/drawingml/2006/main">
               <a:ext uri="{FF2B5EF4-FFF2-40B4-BE49-F238E27FC236}">
-                <a16:creationId xmlns:a16="http://schemas.microsoft.com/office/drawing/2014/main" id="{6E9B820E-153E-4598-BA85-9E1955FA7BFD}"/>
+                <a16:creationId xmlns:a16="http://schemas.microsoft.com/office/drawing/2014/main" id="{541B562C-6B34-4AEC-9634-0E8466B21349}"/>
               </a:ext>
             </a:extLst>
           </p:cNvPr>
@@ -7478,7 +7478,7 @@
           <p:cNvPr id="29" name="flow-28">
             <a:extLst xmlns:a="http://schemas.openxmlformats.org/drawingml/2006/main">
               <a:ext uri="{FF2B5EF4-FFF2-40B4-BE49-F238E27FC236}">
-                <a16:creationId xmlns:a16="http://schemas.microsoft.com/office/drawing/2014/main" id="{61FD5267-A6C8-4736-80B2-952018106CAE}"/>
+                <a16:creationId xmlns:a16="http://schemas.microsoft.com/office/drawing/2014/main" id="{F14C1139-9D81-4D14-9426-B22498488822}"/>
               </a:ext>
             </a:extLst>
           </p:cNvPr>
@@ -7508,7 +7508,7 @@
           <p:cNvPr id="30" name="text-29">
             <a:extLst xmlns:a="http://schemas.openxmlformats.org/drawingml/2006/main">
               <a:ext uri="{FF2B5EF4-FFF2-40B4-BE49-F238E27FC236}">
-                <a16:creationId xmlns:a16="http://schemas.microsoft.com/office/drawing/2014/main" id="{52777E28-FE11-4327-BD08-B64554131B30}"/>
+                <a16:creationId xmlns:a16="http://schemas.microsoft.com/office/drawing/2014/main" id="{0B7038DA-7A8B-41AA-8903-1CD698995481}"/>
               </a:ext>
             </a:extLst>
           </p:cNvPr>
@@ -7666,7 +7666,7 @@
           <p:cNvPr id="31" name="text-30">
             <a:extLst xmlns:a="http://schemas.openxmlformats.org/drawingml/2006/main">
               <a:ext uri="{FF2B5EF4-FFF2-40B4-BE49-F238E27FC236}">
-                <a16:creationId xmlns:a16="http://schemas.microsoft.com/office/drawing/2014/main" id="{E1645A3D-C1CE-4F1B-AA2D-91CF0666C6CE}"/>
+                <a16:creationId xmlns:a16="http://schemas.microsoft.com/office/drawing/2014/main" id="{B4F132FF-A78A-42AD-A477-435333CA4440}"/>
               </a:ext>
             </a:extLst>
           </p:cNvPr>
@@ -7824,7 +7824,7 @@
           <p:cNvPr id="32" name="box-31">
             <a:extLst xmlns:a="http://schemas.openxmlformats.org/drawingml/2006/main">
               <a:ext uri="{FF2B5EF4-FFF2-40B4-BE49-F238E27FC236}">
-                <a16:creationId xmlns:a16="http://schemas.microsoft.com/office/drawing/2014/main" id="{EA4D953C-879D-465E-B0A2-EF37E6581630}"/>
+                <a16:creationId xmlns:a16="http://schemas.microsoft.com/office/drawing/2014/main" id="{D3642EE3-185C-4AED-8D95-D7733BF41CB4}"/>
               </a:ext>
             </a:extLst>
           </p:cNvPr>
@@ -7854,7 +7854,7 @@
           <p:cNvPr id="33" name="text-32">
             <a:extLst xmlns:a="http://schemas.openxmlformats.org/drawingml/2006/main">
               <a:ext uri="{FF2B5EF4-FFF2-40B4-BE49-F238E27FC236}">
-                <a16:creationId xmlns:a16="http://schemas.microsoft.com/office/drawing/2014/main" id="{CE13B6A1-F1D8-41CC-BE24-9E5ECF51942F}"/>
+                <a16:creationId xmlns:a16="http://schemas.microsoft.com/office/drawing/2014/main" id="{3CF85DA8-50FA-4C90-B58D-AF500C634D0F}"/>
               </a:ext>
             </a:extLst>
           </p:cNvPr>
@@ -8010,7 +8010,7 @@
     </p:spTree>
     <p:extLst>
       <p:ext uri="{BB962C8B-B14F-4D97-AF65-F5344CB8AC3E}">
-        <p14:creationId xmlns:p14="http://schemas.microsoft.com/office/powerpoint/2010/main" val="184862619"/>
+        <p14:creationId xmlns:p14="http://schemas.microsoft.com/office/powerpoint/2010/main" val="768645855"/>
       </p:ext>
     </p:extLst>
   </p:cSld>
@@ -8041,7 +8041,7 @@
           <p:cNvPr id="9" name="text-33">
             <a:extLst xmlns:a="http://schemas.openxmlformats.org/drawingml/2006/main">
               <a:ext uri="{FF2B5EF4-FFF2-40B4-BE49-F238E27FC236}">
-                <a16:creationId xmlns:a16="http://schemas.microsoft.com/office/drawing/2014/main" id="{86A0ECB0-16D4-4A32-B6EC-B7C743FBB79A}"/>
+                <a16:creationId xmlns:a16="http://schemas.microsoft.com/office/drawing/2014/main" id="{A6D604BF-8EFC-47CA-8B87-69FF456CC37A}"/>
               </a:ext>
             </a:extLst>
           </p:cNvPr>
@@ -8199,7 +8199,7 @@
           <p:cNvPr id="2" name="text-34">
             <a:extLst xmlns:a="http://schemas.openxmlformats.org/drawingml/2006/main">
               <a:ext uri="{FF2B5EF4-FFF2-40B4-BE49-F238E27FC236}">
-                <a16:creationId xmlns:a16="http://schemas.microsoft.com/office/drawing/2014/main" id="{605F7650-9BB7-42B6-8936-64074C111AEA}"/>
+                <a16:creationId xmlns:a16="http://schemas.microsoft.com/office/drawing/2014/main" id="{134830B2-B666-4787-B261-406310B41DED}"/>
               </a:ext>
             </a:extLst>
           </p:cNvPr>
@@ -8357,7 +8357,7 @@
           <p:cNvPr id="3" name="text-35">
             <a:extLst xmlns:a="http://schemas.openxmlformats.org/drawingml/2006/main">
               <a:ext uri="{FF2B5EF4-FFF2-40B4-BE49-F238E27FC236}">
-                <a16:creationId xmlns:a16="http://schemas.microsoft.com/office/drawing/2014/main" id="{9C4462E4-C27C-45C6-BA35-9297B164C775}"/>
+                <a16:creationId xmlns:a16="http://schemas.microsoft.com/office/drawing/2014/main" id="{69AA16B8-1FCB-41B6-BBD1-D23BE6CD0F0D}"/>
               </a:ext>
             </a:extLst>
           </p:cNvPr>
@@ -8515,7 +8515,7 @@
           <p:cNvPr id="4" name="text-36">
             <a:extLst xmlns:a="http://schemas.openxmlformats.org/drawingml/2006/main">
               <a:ext uri="{FF2B5EF4-FFF2-40B4-BE49-F238E27FC236}">
-                <a16:creationId xmlns:a16="http://schemas.microsoft.com/office/drawing/2014/main" id="{ABBB24CF-389C-4B2B-B02E-B4A3A1F3FCE3}"/>
+                <a16:creationId xmlns:a16="http://schemas.microsoft.com/office/drawing/2014/main" id="{B4AD99E5-C33C-40B4-BBDF-DACB0D560767}"/>
               </a:ext>
             </a:extLst>
           </p:cNvPr>
@@ -8673,7 +8673,7 @@
           <p:cNvPr id="5" name="text-37">
             <a:extLst xmlns:a="http://schemas.openxmlformats.org/drawingml/2006/main">
               <a:ext uri="{FF2B5EF4-FFF2-40B4-BE49-F238E27FC236}">
-                <a16:creationId xmlns:a16="http://schemas.microsoft.com/office/drawing/2014/main" id="{C774A269-F1EF-400F-96E5-BA5440E06592}"/>
+                <a16:creationId xmlns:a16="http://schemas.microsoft.com/office/drawing/2014/main" id="{6403A7ED-046C-49F9-B3D0-EE3B3A33C400}"/>
               </a:ext>
             </a:extLst>
           </p:cNvPr>
@@ -8877,7 +8877,7 @@
           <p:cNvPr id="6" name="text-38">
             <a:extLst xmlns:a="http://schemas.openxmlformats.org/drawingml/2006/main">
               <a:ext uri="{FF2B5EF4-FFF2-40B4-BE49-F238E27FC236}">
-                <a16:creationId xmlns:a16="http://schemas.microsoft.com/office/drawing/2014/main" id="{EC836C9F-979F-4F72-AFC7-B1E45192B79A}"/>
+                <a16:creationId xmlns:a16="http://schemas.microsoft.com/office/drawing/2014/main" id="{5687A7D5-1867-4450-BF73-85B1A64B875C}"/>
               </a:ext>
             </a:extLst>
           </p:cNvPr>
@@ -9081,7 +9081,7 @@
           <p:cNvPr id="7" name="text-39">
             <a:extLst xmlns:a="http://schemas.openxmlformats.org/drawingml/2006/main">
               <a:ext uri="{FF2B5EF4-FFF2-40B4-BE49-F238E27FC236}">
-                <a16:creationId xmlns:a16="http://schemas.microsoft.com/office/drawing/2014/main" id="{05367A97-B275-4DEF-BD08-9943BA48DD1C}"/>
+                <a16:creationId xmlns:a16="http://schemas.microsoft.com/office/drawing/2014/main" id="{59A163CC-F665-40A3-B3D3-44E594530D15}"/>
               </a:ext>
             </a:extLst>
           </p:cNvPr>
@@ -9285,7 +9285,7 @@
           <p:cNvPr id="8" name="">
             <a:extLst xmlns:a="http://schemas.openxmlformats.org/drawingml/2006/main">
               <a:ext uri="{FF2B5EF4-FFF2-40B4-BE49-F238E27FC236}">
-                <a16:creationId xmlns:a16="http://schemas.microsoft.com/office/drawing/2014/main" id="{AD6EDB0E-C322-4F37-901A-C909D9CE547D}"/>
+                <a16:creationId xmlns:a16="http://schemas.microsoft.com/office/drawing/2014/main" id="{C3C2FD6D-CB17-4384-8BE8-B8D97E6760A7}"/>
               </a:ext>
             </a:extLst>
           </p:cNvPr>
@@ -9295,14 +9295,14 @@
           <p:nvPr/>
         </p:nvPicPr>
         <p:blipFill>
-          <a:blip xmlns:r="http://schemas.openxmlformats.org/officeDocument/2006/relationships" xmlns:a="http://schemas.openxmlformats.org/drawingml/2006/main" r:embed="R82190c49bbc54a77"/>
-          <a:srcRect xmlns:a="http://schemas.openxmlformats.org/drawingml/2006/main" l="0" t="0" r="0" b="16000"/>
+          <a:blip xmlns:r="http://schemas.openxmlformats.org/officeDocument/2006/relationships" xmlns:a="http://schemas.openxmlformats.org/drawingml/2006/main" r:embed="R04c0798af9fa42f0"/>
+          <a:srcRect xmlns:a="http://schemas.openxmlformats.org/drawingml/2006/main" l="0" t="0" r="0" b="14500"/>
           <a:stretch xmlns:a="http://schemas.openxmlformats.org/drawingml/2006/main"/>
         </p:blipFill>
         <p:spPr>
           <a:xfrm xmlns:a="http://schemas.openxmlformats.org/drawingml/2006/main">
-            <a:off x="7038975" y="1714500"/>
-            <a:ext cx="3676650" cy="4572000"/>
+            <a:off x="7077075" y="1714500"/>
+            <a:ext cx="3609975" cy="4572000"/>
           </a:xfrm>
           <a:prstGeom xmlns:a="http://schemas.openxmlformats.org/drawingml/2006/main" prst="rect">
             <a:avLst/>
@@ -9312,7 +9312,7 @@
     </p:spTree>
     <p:extLst>
       <p:ext uri="{BB962C8B-B14F-4D97-AF65-F5344CB8AC3E}">
-        <p14:creationId xmlns:p14="http://schemas.microsoft.com/office/powerpoint/2010/main" val="1919970218"/>
+        <p14:creationId xmlns:p14="http://schemas.microsoft.com/office/powerpoint/2010/main" val="349653049"/>
       </p:ext>
     </p:extLst>
   </p:cSld>
@@ -9343,7 +9343,7 @@
           <p:cNvPr id="25" name="text-40">
             <a:extLst xmlns:a="http://schemas.openxmlformats.org/drawingml/2006/main">
               <a:ext uri="{FF2B5EF4-FFF2-40B4-BE49-F238E27FC236}">
-                <a16:creationId xmlns:a16="http://schemas.microsoft.com/office/drawing/2014/main" id="{258BE243-117E-4478-9705-AA9C375C38AA}"/>
+                <a16:creationId xmlns:a16="http://schemas.microsoft.com/office/drawing/2014/main" id="{CD01C0A3-6E29-48F2-ACAB-54335BD6400C}"/>
               </a:ext>
             </a:extLst>
           </p:cNvPr>
@@ -9501,7 +9501,7 @@
           <p:cNvPr id="2" name="text-41">
             <a:extLst xmlns:a="http://schemas.openxmlformats.org/drawingml/2006/main">
               <a:ext uri="{FF2B5EF4-FFF2-40B4-BE49-F238E27FC236}">
-                <a16:creationId xmlns:a16="http://schemas.microsoft.com/office/drawing/2014/main" id="{AFA15F30-270F-4666-912E-B1C2AC4D2E4F}"/>
+                <a16:creationId xmlns:a16="http://schemas.microsoft.com/office/drawing/2014/main" id="{4BB832F8-4956-4FD0-8285-0362D22A51DC}"/>
               </a:ext>
             </a:extLst>
           </p:cNvPr>
@@ -9659,7 +9659,7 @@
           <p:cNvPr id="3" name="text-42">
             <a:extLst xmlns:a="http://schemas.openxmlformats.org/drawingml/2006/main">
               <a:ext uri="{FF2B5EF4-FFF2-40B4-BE49-F238E27FC236}">
-                <a16:creationId xmlns:a16="http://schemas.microsoft.com/office/drawing/2014/main" id="{5133CEDE-61AD-4A45-96EF-38BCD398ACA4}"/>
+                <a16:creationId xmlns:a16="http://schemas.microsoft.com/office/drawing/2014/main" id="{231BD3DF-397E-4FF8-B146-89CE8ED0D164}"/>
               </a:ext>
             </a:extLst>
           </p:cNvPr>
@@ -9817,7 +9817,7 @@
           <p:cNvPr id="4" name="text-43">
             <a:extLst xmlns:a="http://schemas.openxmlformats.org/drawingml/2006/main">
               <a:ext uri="{FF2B5EF4-FFF2-40B4-BE49-F238E27FC236}">
-                <a16:creationId xmlns:a16="http://schemas.microsoft.com/office/drawing/2014/main" id="{99613883-A6E0-400A-ABA2-854CB6742D5D}"/>
+                <a16:creationId xmlns:a16="http://schemas.microsoft.com/office/drawing/2014/main" id="{6FB6F1B1-778A-46BB-9450-9342C0D37A32}"/>
               </a:ext>
             </a:extLst>
           </p:cNvPr>
@@ -9975,7 +9975,7 @@
           <p:cNvPr id="5" name="box-44">
             <a:extLst xmlns:a="http://schemas.openxmlformats.org/drawingml/2006/main">
               <a:ext uri="{FF2B5EF4-FFF2-40B4-BE49-F238E27FC236}">
-                <a16:creationId xmlns:a16="http://schemas.microsoft.com/office/drawing/2014/main" id="{B6EEF3D5-3831-42E2-A09B-E52EE6210839}"/>
+                <a16:creationId xmlns:a16="http://schemas.microsoft.com/office/drawing/2014/main" id="{5D62DE26-F2C8-4A40-8556-E60F7EB3ED94}"/>
               </a:ext>
             </a:extLst>
           </p:cNvPr>
@@ -10005,7 +10005,7 @@
           <p:cNvPr id="6" name="text-45">
             <a:extLst xmlns:a="http://schemas.openxmlformats.org/drawingml/2006/main">
               <a:ext uri="{FF2B5EF4-FFF2-40B4-BE49-F238E27FC236}">
-                <a16:creationId xmlns:a16="http://schemas.microsoft.com/office/drawing/2014/main" id="{868FF002-4770-48B4-8446-A4456B083ACE}"/>
+                <a16:creationId xmlns:a16="http://schemas.microsoft.com/office/drawing/2014/main" id="{39D6E3BD-1B99-42A8-9CB9-AB6E1F0807C2}"/>
               </a:ext>
             </a:extLst>
           </p:cNvPr>
@@ -10163,7 +10163,7 @@
           <p:cNvPr id="7" name="text-46">
             <a:extLst xmlns:a="http://schemas.openxmlformats.org/drawingml/2006/main">
               <a:ext uri="{FF2B5EF4-FFF2-40B4-BE49-F238E27FC236}">
-                <a16:creationId xmlns:a16="http://schemas.microsoft.com/office/drawing/2014/main" id="{6D51AE3A-1D5E-4062-B32E-96D009EB4E49}"/>
+                <a16:creationId xmlns:a16="http://schemas.microsoft.com/office/drawing/2014/main" id="{82DFAD5B-C070-4AE7-9152-DEF29373A766}"/>
               </a:ext>
             </a:extLst>
           </p:cNvPr>
@@ -10311,7 +10311,7 @@
                 <a:ea typeface="Inter"/>
                 <a:cs typeface="Inter"/>
               </a:rPr>
-              <a:t>GSE270392 root atlas</a:t>
+              <a:t>Your H5AD / published root demo</a:t>
             </a:r>
           </a:p>
         </p:txBody>
@@ -10321,7 +10321,7 @@
           <p:cNvPr id="8" name="text-47">
             <a:extLst xmlns:a="http://schemas.openxmlformats.org/drawingml/2006/main">
               <a:ext uri="{FF2B5EF4-FFF2-40B4-BE49-F238E27FC236}">
-                <a16:creationId xmlns:a16="http://schemas.microsoft.com/office/drawing/2014/main" id="{971E7A71-3B40-4DC1-8AFB-719824ACFD77}"/>
+                <a16:creationId xmlns:a16="http://schemas.microsoft.com/office/drawing/2014/main" id="{AF578F5F-45AE-48E6-8E34-C3C28BC59A3F}"/>
               </a:ext>
             </a:extLst>
           </p:cNvPr>
@@ -10479,7 +10479,7 @@
           <p:cNvPr id="9" name="flow-48">
             <a:extLst xmlns:a="http://schemas.openxmlformats.org/drawingml/2006/main">
               <a:ext uri="{FF2B5EF4-FFF2-40B4-BE49-F238E27FC236}">
-                <a16:creationId xmlns:a16="http://schemas.microsoft.com/office/drawing/2014/main" id="{4661F5A3-2B22-41A2-B4C9-AFB44394CD91}"/>
+                <a16:creationId xmlns:a16="http://schemas.microsoft.com/office/drawing/2014/main" id="{2DEB300C-DED6-4E95-AAA2-BD2FCEC8F947}"/>
               </a:ext>
             </a:extLst>
           </p:cNvPr>
@@ -10509,7 +10509,7 @@
           <p:cNvPr id="10" name="box-49">
             <a:extLst xmlns:a="http://schemas.openxmlformats.org/drawingml/2006/main">
               <a:ext uri="{FF2B5EF4-FFF2-40B4-BE49-F238E27FC236}">
-                <a16:creationId xmlns:a16="http://schemas.microsoft.com/office/drawing/2014/main" id="{3FA4F1AC-0835-41B3-B49D-BC4C2561176E}"/>
+                <a16:creationId xmlns:a16="http://schemas.microsoft.com/office/drawing/2014/main" id="{2B166AFE-8839-4B84-AB81-024CD8702F56}"/>
               </a:ext>
             </a:extLst>
           </p:cNvPr>
@@ -10539,7 +10539,7 @@
           <p:cNvPr id="11" name="text-50">
             <a:extLst xmlns:a="http://schemas.openxmlformats.org/drawingml/2006/main">
               <a:ext uri="{FF2B5EF4-FFF2-40B4-BE49-F238E27FC236}">
-                <a16:creationId xmlns:a16="http://schemas.microsoft.com/office/drawing/2014/main" id="{054AFF67-6E9F-4F74-9FF7-1533D7624235}"/>
+                <a16:creationId xmlns:a16="http://schemas.microsoft.com/office/drawing/2014/main" id="{23A6EF01-1BEC-4B90-9F85-1D123EC671C0}"/>
               </a:ext>
             </a:extLst>
           </p:cNvPr>
@@ -10697,7 +10697,7 @@
           <p:cNvPr id="12" name="text-51">
             <a:extLst xmlns:a="http://schemas.openxmlformats.org/drawingml/2006/main">
               <a:ext uri="{FF2B5EF4-FFF2-40B4-BE49-F238E27FC236}">
-                <a16:creationId xmlns:a16="http://schemas.microsoft.com/office/drawing/2014/main" id="{E0BB3B30-848B-40E7-AE90-1C7922061089}"/>
+                <a16:creationId xmlns:a16="http://schemas.microsoft.com/office/drawing/2014/main" id="{25EF173E-9E6E-4CF3-8F70-91A78E7F3E65}"/>
               </a:ext>
             </a:extLst>
           </p:cNvPr>
@@ -10855,7 +10855,7 @@
           <p:cNvPr id="13" name="text-52">
             <a:extLst xmlns:a="http://schemas.openxmlformats.org/drawingml/2006/main">
               <a:ext uri="{FF2B5EF4-FFF2-40B4-BE49-F238E27FC236}">
-                <a16:creationId xmlns:a16="http://schemas.microsoft.com/office/drawing/2014/main" id="{A9A883CC-31FA-4228-BB88-417E38B3F9AC}"/>
+                <a16:creationId xmlns:a16="http://schemas.microsoft.com/office/drawing/2014/main" id="{9729E56C-35F7-471E-9740-8F3620E8DA2B}"/>
               </a:ext>
             </a:extLst>
           </p:cNvPr>
@@ -11013,7 +11013,7 @@
           <p:cNvPr id="14" name="flow-53">
             <a:extLst xmlns:a="http://schemas.openxmlformats.org/drawingml/2006/main">
               <a:ext uri="{FF2B5EF4-FFF2-40B4-BE49-F238E27FC236}">
-                <a16:creationId xmlns:a16="http://schemas.microsoft.com/office/drawing/2014/main" id="{D4EAED9E-C38B-4183-85BA-1C3B703D2E45}"/>
+                <a16:creationId xmlns:a16="http://schemas.microsoft.com/office/drawing/2014/main" id="{65C89316-684B-4AE6-B18B-C2A2E02E0F54}"/>
               </a:ext>
             </a:extLst>
           </p:cNvPr>
@@ -11043,7 +11043,7 @@
           <p:cNvPr id="15" name="box-54">
             <a:extLst xmlns:a="http://schemas.openxmlformats.org/drawingml/2006/main">
               <a:ext uri="{FF2B5EF4-FFF2-40B4-BE49-F238E27FC236}">
-                <a16:creationId xmlns:a16="http://schemas.microsoft.com/office/drawing/2014/main" id="{C94D3234-C6D1-43D8-8B02-122B93170BF2}"/>
+                <a16:creationId xmlns:a16="http://schemas.microsoft.com/office/drawing/2014/main" id="{B7D00D8F-1B53-4F1E-95D1-9ACCF10D1853}"/>
               </a:ext>
             </a:extLst>
           </p:cNvPr>
@@ -11073,7 +11073,7 @@
           <p:cNvPr id="16" name="text-55">
             <a:extLst xmlns:a="http://schemas.openxmlformats.org/drawingml/2006/main">
               <a:ext uri="{FF2B5EF4-FFF2-40B4-BE49-F238E27FC236}">
-                <a16:creationId xmlns:a16="http://schemas.microsoft.com/office/drawing/2014/main" id="{1494152F-CFB0-447F-B7B1-11AF606EE2BD}"/>
+                <a16:creationId xmlns:a16="http://schemas.microsoft.com/office/drawing/2014/main" id="{80ED4283-4B7B-4B85-A993-ED905054329D}"/>
               </a:ext>
             </a:extLst>
           </p:cNvPr>
@@ -11231,7 +11231,7 @@
           <p:cNvPr id="17" name="text-56">
             <a:extLst xmlns:a="http://schemas.openxmlformats.org/drawingml/2006/main">
               <a:ext uri="{FF2B5EF4-FFF2-40B4-BE49-F238E27FC236}">
-                <a16:creationId xmlns:a16="http://schemas.microsoft.com/office/drawing/2014/main" id="{93B72A22-0A77-4760-A1C6-847FE239DC24}"/>
+                <a16:creationId xmlns:a16="http://schemas.microsoft.com/office/drawing/2014/main" id="{6BAE9FBD-8ACF-4CAD-BFD4-F4E47D6CF7F6}"/>
               </a:ext>
             </a:extLst>
           </p:cNvPr>
@@ -11389,7 +11389,7 @@
           <p:cNvPr id="18" name="text-57">
             <a:extLst xmlns:a="http://schemas.openxmlformats.org/drawingml/2006/main">
               <a:ext uri="{FF2B5EF4-FFF2-40B4-BE49-F238E27FC236}">
-                <a16:creationId xmlns:a16="http://schemas.microsoft.com/office/drawing/2014/main" id="{C48EF086-ED0E-4C8E-B99A-5366DDF6E02E}"/>
+                <a16:creationId xmlns:a16="http://schemas.microsoft.com/office/drawing/2014/main" id="{C7463A5B-40E8-4361-A1BA-F0BFBD21908F}"/>
               </a:ext>
             </a:extLst>
           </p:cNvPr>
@@ -11547,7 +11547,7 @@
           <p:cNvPr id="19" name="flow-58">
             <a:extLst xmlns:a="http://schemas.openxmlformats.org/drawingml/2006/main">
               <a:ext uri="{FF2B5EF4-FFF2-40B4-BE49-F238E27FC236}">
-                <a16:creationId xmlns:a16="http://schemas.microsoft.com/office/drawing/2014/main" id="{BB2243B2-9EA6-4A2A-A260-46CCA2810661}"/>
+                <a16:creationId xmlns:a16="http://schemas.microsoft.com/office/drawing/2014/main" id="{4EC54754-289F-45F2-BF2B-4C4887D12533}"/>
               </a:ext>
             </a:extLst>
           </p:cNvPr>
@@ -11577,7 +11577,7 @@
           <p:cNvPr id="20" name="box-59">
             <a:extLst xmlns:a="http://schemas.openxmlformats.org/drawingml/2006/main">
               <a:ext uri="{FF2B5EF4-FFF2-40B4-BE49-F238E27FC236}">
-                <a16:creationId xmlns:a16="http://schemas.microsoft.com/office/drawing/2014/main" id="{93990E32-3123-4447-8B54-434D4466EB4A}"/>
+                <a16:creationId xmlns:a16="http://schemas.microsoft.com/office/drawing/2014/main" id="{52B81102-BCFF-45D8-818C-198A52302127}"/>
               </a:ext>
             </a:extLst>
           </p:cNvPr>
@@ -11607,7 +11607,7 @@
           <p:cNvPr id="21" name="text-60">
             <a:extLst xmlns:a="http://schemas.openxmlformats.org/drawingml/2006/main">
               <a:ext uri="{FF2B5EF4-FFF2-40B4-BE49-F238E27FC236}">
-                <a16:creationId xmlns:a16="http://schemas.microsoft.com/office/drawing/2014/main" id="{D1EB9F19-C8D3-4D9F-8250-5AD74FF9632F}"/>
+                <a16:creationId xmlns:a16="http://schemas.microsoft.com/office/drawing/2014/main" id="{AD1F0DC7-8012-4742-8631-5610249B5F91}"/>
               </a:ext>
             </a:extLst>
           </p:cNvPr>
@@ -11765,7 +11765,7 @@
           <p:cNvPr id="22" name="text-61">
             <a:extLst xmlns:a="http://schemas.openxmlformats.org/drawingml/2006/main">
               <a:ext uri="{FF2B5EF4-FFF2-40B4-BE49-F238E27FC236}">
-                <a16:creationId xmlns:a16="http://schemas.microsoft.com/office/drawing/2014/main" id="{3B79F52A-2C43-45A2-A028-0A85743458DE}"/>
+                <a16:creationId xmlns:a16="http://schemas.microsoft.com/office/drawing/2014/main" id="{A21C363D-94CF-409F-9500-5A57D69CD0E5}"/>
               </a:ext>
             </a:extLst>
           </p:cNvPr>
@@ -11969,7 +11969,7 @@
           <p:cNvPr id="23" name="text-62">
             <a:extLst xmlns:a="http://schemas.openxmlformats.org/drawingml/2006/main">
               <a:ext uri="{FF2B5EF4-FFF2-40B4-BE49-F238E27FC236}">
-                <a16:creationId xmlns:a16="http://schemas.microsoft.com/office/drawing/2014/main" id="{C3D29D8D-7633-4E2F-B8E4-F539B04237BD}"/>
+                <a16:creationId xmlns:a16="http://schemas.microsoft.com/office/drawing/2014/main" id="{6A63605A-5148-4842-90AA-DC724487425C}"/>
               </a:ext>
             </a:extLst>
           </p:cNvPr>
@@ -12150,7 +12150,7 @@
           <p:cNvPr id="24" name="text-63">
             <a:extLst xmlns:a="http://schemas.openxmlformats.org/drawingml/2006/main">
               <a:ext uri="{FF2B5EF4-FFF2-40B4-BE49-F238E27FC236}">
-                <a16:creationId xmlns:a16="http://schemas.microsoft.com/office/drawing/2014/main" id="{0DDEFE50-C487-4089-9811-35C52E9E78A4}"/>
+                <a16:creationId xmlns:a16="http://schemas.microsoft.com/office/drawing/2014/main" id="{55C287CC-8037-431F-ABFA-AA95F6A9EE3D}"/>
               </a:ext>
             </a:extLst>
           </p:cNvPr>
@@ -12298,7 +12298,7 @@
                 <a:ea typeface="Inter"/>
                 <a:cs typeface="Inter"/>
               </a:rPr>
-              <a:t>Next connections: H5AD uploads, SoyBase mapping, live orthology and nodule reference panels.</a:t>
+              <a:t>Next connections: SoyBase mapping, live orthology and compatible nodule reference panels.</a:t>
             </a:r>
           </a:p>
         </p:txBody>
@@ -12306,7 +12306,7 @@
     </p:spTree>
     <p:extLst>
       <p:ext uri="{BB962C8B-B14F-4D97-AF65-F5344CB8AC3E}">
-        <p14:creationId xmlns:p14="http://schemas.microsoft.com/office/powerpoint/2010/main" val="254340844"/>
+        <p14:creationId xmlns:p14="http://schemas.microsoft.com/office/powerpoint/2010/main" val="2105700232"/>
       </p:ext>
     </p:extLst>
   </p:cSld>
@@ -12334,10 +12334,10 @@
       </p:grpSpPr>
       <p:sp>
         <p:nvSpPr>
-          <p:cNvPr id="11" name="text-64">
+          <p:cNvPr id="15" name="text-64">
             <a:extLst xmlns:a="http://schemas.openxmlformats.org/drawingml/2006/main">
               <a:ext uri="{FF2B5EF4-FFF2-40B4-BE49-F238E27FC236}">
-                <a16:creationId xmlns:a16="http://schemas.microsoft.com/office/drawing/2014/main" id="{5D0D628B-67EF-4012-BFA8-591CBDD38AA6}"/>
+                <a16:creationId xmlns:a16="http://schemas.microsoft.com/office/drawing/2014/main" id="{F7C9ED9B-2425-4862-B6AC-090CAE1F057E}"/>
               </a:ext>
             </a:extLst>
           </p:cNvPr>
@@ -12495,7 +12495,7 @@
           <p:cNvPr id="2" name="text-65">
             <a:extLst xmlns:a="http://schemas.openxmlformats.org/drawingml/2006/main">
               <a:ext uri="{FF2B5EF4-FFF2-40B4-BE49-F238E27FC236}">
-                <a16:creationId xmlns:a16="http://schemas.microsoft.com/office/drawing/2014/main" id="{2255B0AC-7811-4679-B154-0857B7B4FAC6}"/>
+                <a16:creationId xmlns:a16="http://schemas.microsoft.com/office/drawing/2014/main" id="{AA3E8714-0FC1-48A4-BB7A-543DF1BD5C35}"/>
               </a:ext>
             </a:extLst>
           </p:cNvPr>
@@ -12653,7 +12653,7 @@
           <p:cNvPr id="3" name="text-66">
             <a:extLst xmlns:a="http://schemas.openxmlformats.org/drawingml/2006/main">
               <a:ext uri="{FF2B5EF4-FFF2-40B4-BE49-F238E27FC236}">
-                <a16:creationId xmlns:a16="http://schemas.microsoft.com/office/drawing/2014/main" id="{6BA83135-C056-40C0-8450-7A9DC242D39D}"/>
+                <a16:creationId xmlns:a16="http://schemas.microsoft.com/office/drawing/2014/main" id="{6A9EFD26-B14F-415A-B68B-BC3DAD2D62F6}"/>
               </a:ext>
             </a:extLst>
           </p:cNvPr>
@@ -12811,7 +12811,7 @@
           <p:cNvPr id="4" name="text-67">
             <a:extLst xmlns:a="http://schemas.openxmlformats.org/drawingml/2006/main">
               <a:ext uri="{FF2B5EF4-FFF2-40B4-BE49-F238E27FC236}">
-                <a16:creationId xmlns:a16="http://schemas.microsoft.com/office/drawing/2014/main" id="{B83D578F-E4E3-4382-9B4E-13A6D7183763}"/>
+                <a16:creationId xmlns:a16="http://schemas.microsoft.com/office/drawing/2014/main" id="{DE9656F6-2F73-402D-A9F3-37B1840823BA}"/>
               </a:ext>
             </a:extLst>
           </p:cNvPr>
@@ -12969,7 +12969,7 @@
           <p:cNvPr id="5" name="text-68">
             <a:extLst xmlns:a="http://schemas.openxmlformats.org/drawingml/2006/main">
               <a:ext uri="{FF2B5EF4-FFF2-40B4-BE49-F238E27FC236}">
-                <a16:creationId xmlns:a16="http://schemas.microsoft.com/office/drawing/2014/main" id="{C28A6B7D-A64E-4145-A920-30D01CE5FBDF}"/>
+                <a16:creationId xmlns:a16="http://schemas.microsoft.com/office/drawing/2014/main" id="{27F0D24B-1745-43BF-AD0D-13E0576987BD}"/>
               </a:ext>
             </a:extLst>
           </p:cNvPr>
@@ -13127,7 +13127,7 @@
           <p:cNvPr id="6" name="box-69">
             <a:extLst xmlns:a="http://schemas.openxmlformats.org/drawingml/2006/main">
               <a:ext uri="{FF2B5EF4-FFF2-40B4-BE49-F238E27FC236}">
-                <a16:creationId xmlns:a16="http://schemas.microsoft.com/office/drawing/2014/main" id="{BA291A2E-F05C-465B-BCFA-E7B2A653523D}"/>
+                <a16:creationId xmlns:a16="http://schemas.microsoft.com/office/drawing/2014/main" id="{BDFDEA5B-0F28-4211-910B-1DD465E745A6}"/>
               </a:ext>
             </a:extLst>
           </p:cNvPr>
@@ -13157,7 +13157,7 @@
           <p:cNvPr id="7" name="text-70">
             <a:extLst xmlns:a="http://schemas.openxmlformats.org/drawingml/2006/main">
               <a:ext uri="{FF2B5EF4-FFF2-40B4-BE49-F238E27FC236}">
-                <a16:creationId xmlns:a16="http://schemas.microsoft.com/office/drawing/2014/main" id="{3A8B59B5-0665-4EDC-A5B3-62F51A5B4C66}"/>
+                <a16:creationId xmlns:a16="http://schemas.microsoft.com/office/drawing/2014/main" id="{8F4210F0-01C3-49C1-AA67-EF6F0F599F3E}"/>
               </a:ext>
             </a:extLst>
           </p:cNvPr>
@@ -13384,7 +13384,7 @@
           <p:cNvPr id="8" name="text-71">
             <a:extLst xmlns:a="http://schemas.openxmlformats.org/drawingml/2006/main">
               <a:ext uri="{FF2B5EF4-FFF2-40B4-BE49-F238E27FC236}">
-                <a16:creationId xmlns:a16="http://schemas.microsoft.com/office/drawing/2014/main" id="{A1A8FE24-500F-4C5E-B181-F1CD8257251E}"/>
+                <a16:creationId xmlns:a16="http://schemas.microsoft.com/office/drawing/2014/main" id="{DF566C6A-603D-4339-A57B-01EE0B1D6A14}"/>
               </a:ext>
             </a:extLst>
           </p:cNvPr>
@@ -13395,8 +13395,8 @@
         </p:nvSpPr>
         <p:spPr>
           <a:xfrm xmlns:a="http://schemas.openxmlformats.org/drawingml/2006/main">
-            <a:off x="552450" y="4457700"/>
-            <a:ext cx="5924550" cy="1143000"/>
+            <a:off x="552450" y="4191000"/>
+            <a:ext cx="5924550" cy="857250"/>
           </a:xfrm>
           <a:prstGeom xmlns:a="http://schemas.openxmlformats.org/drawingml/2006/main" prst="rect">
             <a:avLst/>
@@ -13412,7 +13412,7 @@
           </a:bodyPr>
           <a:lstStyle xmlns:a="http://schemas.openxmlformats.org/drawingml/2006/main">
             <a:defPPr>
-              <a:defRPr sz="1875" b="0">
+              <a:defRPr sz="1800" b="0">
                 <a:solidFill>
                   <a:srgbClr val="14221A"/>
                 </a:solidFill>
@@ -13422,7 +13422,7 @@
               </a:defRPr>
             </a:defPPr>
             <a:lvl1pPr>
-              <a:defRPr sz="1875" b="0">
+              <a:defRPr sz="1800" b="0">
                 <a:solidFill>
                   <a:srgbClr val="14221A"/>
                 </a:solidFill>
@@ -13432,7 +13432,7 @@
               </a:defRPr>
             </a:lvl1pPr>
             <a:lvl2pPr>
-              <a:defRPr sz="1875" b="0">
+              <a:defRPr sz="1800" b="0">
                 <a:solidFill>
                   <a:srgbClr val="14221A"/>
                 </a:solidFill>
@@ -13442,7 +13442,7 @@
               </a:defRPr>
             </a:lvl2pPr>
             <a:lvl3pPr>
-              <a:defRPr sz="1875" b="0">
+              <a:defRPr sz="1800" b="0">
                 <a:solidFill>
                   <a:srgbClr val="14221A"/>
                 </a:solidFill>
@@ -13452,7 +13452,7 @@
               </a:defRPr>
             </a:lvl3pPr>
             <a:lvl4pPr>
-              <a:defRPr sz="1875" b="0">
+              <a:defRPr sz="1800" b="0">
                 <a:solidFill>
                   <a:srgbClr val="14221A"/>
                 </a:solidFill>
@@ -13462,7 +13462,7 @@
               </a:defRPr>
             </a:lvl4pPr>
             <a:lvl5pPr>
-              <a:defRPr sz="1875" b="0">
+              <a:defRPr sz="1800" b="0">
                 <a:solidFill>
                   <a:srgbClr val="14221A"/>
                 </a:solidFill>
@@ -13472,7 +13472,7 @@
               </a:defRPr>
             </a:lvl5pPr>
             <a:lvl6pPr>
-              <a:defRPr sz="1875" b="0">
+              <a:defRPr sz="1800" b="0">
                 <a:solidFill>
                   <a:srgbClr val="14221A"/>
                 </a:solidFill>
@@ -13482,7 +13482,7 @@
               </a:defRPr>
             </a:lvl6pPr>
             <a:lvl7pPr>
-              <a:defRPr sz="1875" b="0">
+              <a:defRPr sz="1800" b="0">
                 <a:solidFill>
                   <a:srgbClr val="14221A"/>
                 </a:solidFill>
@@ -13492,7 +13492,7 @@
               </a:defRPr>
             </a:lvl7pPr>
             <a:lvl8pPr>
-              <a:defRPr sz="1875" b="0">
+              <a:defRPr sz="1800" b="0">
                 <a:solidFill>
                   <a:srgbClr val="14221A"/>
                 </a:solidFill>
@@ -13502,7 +13502,7 @@
               </a:defRPr>
             </a:lvl8pPr>
             <a:lvl9pPr>
-              <a:defRPr sz="1875" b="0">
+              <a:defRPr sz="1800" b="0">
                 <a:solidFill>
                   <a:srgbClr val="14221A"/>
                 </a:solidFill>
@@ -13514,7 +13514,7 @@
           </a:lstStyle>
           <a:p xmlns:a="http://schemas.openxmlformats.org/drawingml/2006/main">
             <a:pPr>
-              <a:defRPr sz="1875" b="0">
+              <a:defRPr sz="1800" b="0">
                 <a:solidFill>
                   <a:srgbClr val="14221A"/>
                 </a:solidFill>
@@ -13524,7 +13524,7 @@
               </a:defRPr>
             </a:pPr>
             <a:r>
-              <a:rPr sz="1875" b="0">
+              <a:rPr sz="1800" b="0">
                 <a:solidFill>
                   <a:srgbClr val="14221A"/>
                 </a:solidFill>
@@ -13537,7 +13537,7 @@
           </a:p>
           <a:p xmlns:a="http://schemas.openxmlformats.org/drawingml/2006/main">
             <a:pPr>
-              <a:defRPr sz="1875" b="0">
+              <a:defRPr sz="1800" b="0">
                 <a:solidFill>
                   <a:srgbClr val="14221A"/>
                 </a:solidFill>
@@ -13547,7 +13547,7 @@
               </a:defRPr>
             </a:pPr>
             <a:r>
-              <a:rPr sz="1875" b="0">
+              <a:rPr sz="1800" b="0">
                 <a:solidFill>
                   <a:srgbClr val="14221A"/>
                 </a:solidFill>
@@ -13560,7 +13560,7 @@
           </a:p>
           <a:p xmlns:a="http://schemas.openxmlformats.org/drawingml/2006/main">
             <a:pPr>
-              <a:defRPr sz="1875" b="0">
+              <a:defRPr sz="1800" b="0">
                 <a:solidFill>
                   <a:srgbClr val="14221A"/>
                 </a:solidFill>
@@ -13570,7 +13570,7 @@
               </a:defRPr>
             </a:pPr>
             <a:r>
-              <a:rPr sz="1875" b="0">
+              <a:rPr sz="1800" b="0">
                 <a:solidFill>
                   <a:srgbClr val="14221A"/>
                 </a:solidFill>
@@ -13585,10 +13585,10 @@
       </p:sp>
       <p:sp>
         <p:nvSpPr>
-          <p:cNvPr id="9" name="text-72">
+          <p:cNvPr id="9" name="box-72">
             <a:extLst xmlns:a="http://schemas.openxmlformats.org/drawingml/2006/main">
               <a:ext uri="{FF2B5EF4-FFF2-40B4-BE49-F238E27FC236}">
-                <a16:creationId xmlns:a16="http://schemas.microsoft.com/office/drawing/2014/main" id="{E700F9D5-BDEB-42D4-BF77-8F65DB2953F4}"/>
+                <a16:creationId xmlns:a16="http://schemas.microsoft.com/office/drawing/2014/main" id="{44A9F024-F65E-4CEE-9CE6-8A2B9D63E866}"/>
               </a:ext>
             </a:extLst>
           </p:cNvPr>
@@ -13599,8 +13599,38 @@
         </p:nvSpPr>
         <p:spPr>
           <a:xfrm xmlns:a="http://schemas.openxmlformats.org/drawingml/2006/main">
-            <a:off x="552450" y="5905500"/>
-            <a:ext cx="6000750" cy="400050"/>
+            <a:off x="6953250" y="2647950"/>
+            <a:ext cx="4705350" cy="2343150"/>
+          </a:xfrm>
+          <a:prstGeom xmlns:a="http://schemas.openxmlformats.org/drawingml/2006/main" prst="rect">
+            <a:avLst/>
+          </a:prstGeom>
+          <a:solidFill xmlns:a="http://schemas.openxmlformats.org/drawingml/2006/main">
+            <a:srgbClr val="F0F5ED"/>
+          </a:solidFill>
+          <a:ln xmlns:a="http://schemas.openxmlformats.org/drawingml/2006/main" w="0">
+            <a:noFill/>
+          </a:ln>
+        </p:spPr>
+      </p:sp>
+      <p:sp>
+        <p:nvSpPr>
+          <p:cNvPr id="10" name="text-73">
+            <a:extLst xmlns:a="http://schemas.openxmlformats.org/drawingml/2006/main">
+              <a:ext uri="{FF2B5EF4-FFF2-40B4-BE49-F238E27FC236}">
+                <a16:creationId xmlns:a16="http://schemas.microsoft.com/office/drawing/2014/main" id="{97522B40-E6EA-4F23-9248-8F676852D816}"/>
+              </a:ext>
+            </a:extLst>
+          </p:cNvPr>
+          <p:cNvSpPr>
+            <a:spLocks xmlns:a="http://schemas.openxmlformats.org/drawingml/2006/main" noGrp="1"/>
+          </p:cNvSpPr>
+          <p:nvPr/>
+        </p:nvSpPr>
+        <p:spPr>
+          <a:xfrm xmlns:a="http://schemas.openxmlformats.org/drawingml/2006/main">
+            <a:off x="7162800" y="2809875"/>
+            <a:ext cx="4267200" cy="866775"/>
           </a:xfrm>
           <a:prstGeom xmlns:a="http://schemas.openxmlformats.org/drawingml/2006/main" prst="rect">
             <a:avLst/>
@@ -13616,7 +13646,7 @@
           </a:bodyPr>
           <a:lstStyle xmlns:a="http://schemas.openxmlformats.org/drawingml/2006/main">
             <a:defPPr>
-              <a:defRPr sz="1650" b="1">
+              <a:defRPr sz="5850" b="1">
                 <a:solidFill>
                   <a:srgbClr val="1B5E20"/>
                 </a:solidFill>
@@ -13626,7 +13656,7 @@
               </a:defRPr>
             </a:defPPr>
             <a:lvl1pPr>
-              <a:defRPr sz="1650" b="1">
+              <a:defRPr sz="5850" b="1">
                 <a:solidFill>
                   <a:srgbClr val="1B5E20"/>
                 </a:solidFill>
@@ -13636,7 +13666,7 @@
               </a:defRPr>
             </a:lvl1pPr>
             <a:lvl2pPr>
-              <a:defRPr sz="1650" b="1">
+              <a:defRPr sz="5850" b="1">
                 <a:solidFill>
                   <a:srgbClr val="1B5E20"/>
                 </a:solidFill>
@@ -13646,7 +13676,7 @@
               </a:defRPr>
             </a:lvl2pPr>
             <a:lvl3pPr>
-              <a:defRPr sz="1650" b="1">
+              <a:defRPr sz="5850" b="1">
                 <a:solidFill>
                   <a:srgbClr val="1B5E20"/>
                 </a:solidFill>
@@ -13656,7 +13686,7 @@
               </a:defRPr>
             </a:lvl3pPr>
             <a:lvl4pPr>
-              <a:defRPr sz="1650" b="1">
+              <a:defRPr sz="5850" b="1">
                 <a:solidFill>
                   <a:srgbClr val="1B5E20"/>
                 </a:solidFill>
@@ -13666,7 +13696,7 @@
               </a:defRPr>
             </a:lvl4pPr>
             <a:lvl5pPr>
-              <a:defRPr sz="1650" b="1">
+              <a:defRPr sz="5850" b="1">
                 <a:solidFill>
                   <a:srgbClr val="1B5E20"/>
                 </a:solidFill>
@@ -13676,7 +13706,7 @@
               </a:defRPr>
             </a:lvl5pPr>
             <a:lvl6pPr>
-              <a:defRPr sz="1650" b="1">
+              <a:defRPr sz="5850" b="1">
                 <a:solidFill>
                   <a:srgbClr val="1B5E20"/>
                 </a:solidFill>
@@ -13686,7 +13716,7 @@
               </a:defRPr>
             </a:lvl6pPr>
             <a:lvl7pPr>
-              <a:defRPr sz="1650" b="1">
+              <a:defRPr sz="5850" b="1">
                 <a:solidFill>
                   <a:srgbClr val="1B5E20"/>
                 </a:solidFill>
@@ -13696,7 +13726,7 @@
               </a:defRPr>
             </a:lvl7pPr>
             <a:lvl8pPr>
-              <a:defRPr sz="1650" b="1">
+              <a:defRPr sz="5850" b="1">
                 <a:solidFill>
                   <a:srgbClr val="1B5E20"/>
                 </a:solidFill>
@@ -13706,7 +13736,7 @@
               </a:defRPr>
             </a:lvl8pPr>
             <a:lvl9pPr>
-              <a:defRPr sz="1650" b="1">
+              <a:defRPr sz="5850" b="1">
                 <a:solidFill>
                   <a:srgbClr val="1B5E20"/>
                 </a:solidFill>
@@ -13718,7 +13748,7 @@
           </a:lstStyle>
           <a:p xmlns:a="http://schemas.openxmlformats.org/drawingml/2006/main">
             <a:pPr>
-              <a:defRPr sz="1650" b="1">
+              <a:defRPr sz="5850" b="1">
                 <a:solidFill>
                   <a:srgbClr val="1B5E20"/>
                 </a:solidFill>
@@ -13728,7 +13758,7 @@
               </a:defRPr>
             </a:pPr>
             <a:r>
-              <a:rPr sz="1650" b="1">
+              <a:rPr sz="5850" b="1">
                 <a:solidFill>
                   <a:srgbClr val="1B5E20"/>
                 </a:solidFill>
@@ -13736,17 +13766,491 @@
                 <a:ea typeface="Inter"/>
                 <a:cs typeface="Inter"/>
               </a:rPr>
-              <a:t>If retrieval or verification fails, annotation stops.</a:t>
+              <a:t>42</a:t>
+            </a:r>
+          </a:p>
+        </p:txBody>
+      </p:sp>
+      <p:sp>
+        <p:nvSpPr>
+          <p:cNvPr id="11" name="text-74">
+            <a:extLst xmlns:a="http://schemas.openxmlformats.org/drawingml/2006/main">
+              <a:ext uri="{FF2B5EF4-FFF2-40B4-BE49-F238E27FC236}">
+                <a16:creationId xmlns:a16="http://schemas.microsoft.com/office/drawing/2014/main" id="{5042D99D-16B5-47FE-8D0A-D3081401FCCA}"/>
+              </a:ext>
+            </a:extLst>
+          </p:cNvPr>
+          <p:cNvSpPr>
+            <a:spLocks xmlns:a="http://schemas.openxmlformats.org/drawingml/2006/main" noGrp="1"/>
+          </p:cNvSpPr>
+          <p:nvPr/>
+        </p:nvSpPr>
+        <p:spPr>
+          <a:xfrm xmlns:a="http://schemas.openxmlformats.org/drawingml/2006/main">
+            <a:off x="7162800" y="3676650"/>
+            <a:ext cx="4267200" cy="371475"/>
+          </a:xfrm>
+          <a:prstGeom xmlns:a="http://schemas.openxmlformats.org/drawingml/2006/main" prst="rect">
+            <a:avLst/>
+          </a:prstGeom>
+          <a:noFill xmlns:a="http://schemas.openxmlformats.org/drawingml/2006/main"/>
+          <a:ln xmlns:a="http://schemas.openxmlformats.org/drawingml/2006/main" w="0">
+            <a:noFill/>
+          </a:ln>
+        </p:spPr>
+        <p:txBody>
+          <a:bodyPr xmlns:a="http://schemas.openxmlformats.org/drawingml/2006/main" wrap="square" lIns="0" tIns="0" rIns="0" bIns="0">
+            <a:noAutofit/>
+          </a:bodyPr>
+          <a:lstStyle xmlns:a="http://schemas.openxmlformats.org/drawingml/2006/main">
+            <a:defPPr>
+              <a:defRPr sz="2025" b="1">
+                <a:solidFill>
+                  <a:srgbClr val="14221A"/>
+                </a:solidFill>
+                <a:latin typeface="Inter"/>
+                <a:ea typeface="Inter"/>
+                <a:cs typeface="Inter"/>
+              </a:defRPr>
+            </a:defPPr>
+            <a:lvl1pPr>
+              <a:defRPr sz="2025" b="1">
+                <a:solidFill>
+                  <a:srgbClr val="14221A"/>
+                </a:solidFill>
+                <a:latin typeface="Inter"/>
+                <a:ea typeface="Inter"/>
+                <a:cs typeface="Inter"/>
+              </a:defRPr>
+            </a:lvl1pPr>
+            <a:lvl2pPr>
+              <a:defRPr sz="2025" b="1">
+                <a:solidFill>
+                  <a:srgbClr val="14221A"/>
+                </a:solidFill>
+                <a:latin typeface="Inter"/>
+                <a:ea typeface="Inter"/>
+                <a:cs typeface="Inter"/>
+              </a:defRPr>
+            </a:lvl2pPr>
+            <a:lvl3pPr>
+              <a:defRPr sz="2025" b="1">
+                <a:solidFill>
+                  <a:srgbClr val="14221A"/>
+                </a:solidFill>
+                <a:latin typeface="Inter"/>
+                <a:ea typeface="Inter"/>
+                <a:cs typeface="Inter"/>
+              </a:defRPr>
+            </a:lvl3pPr>
+            <a:lvl4pPr>
+              <a:defRPr sz="2025" b="1">
+                <a:solidFill>
+                  <a:srgbClr val="14221A"/>
+                </a:solidFill>
+                <a:latin typeface="Inter"/>
+                <a:ea typeface="Inter"/>
+                <a:cs typeface="Inter"/>
+              </a:defRPr>
+            </a:lvl4pPr>
+            <a:lvl5pPr>
+              <a:defRPr sz="2025" b="1">
+                <a:solidFill>
+                  <a:srgbClr val="14221A"/>
+                </a:solidFill>
+                <a:latin typeface="Inter"/>
+                <a:ea typeface="Inter"/>
+                <a:cs typeface="Inter"/>
+              </a:defRPr>
+            </a:lvl5pPr>
+            <a:lvl6pPr>
+              <a:defRPr sz="2025" b="1">
+                <a:solidFill>
+                  <a:srgbClr val="14221A"/>
+                </a:solidFill>
+                <a:latin typeface="Inter"/>
+                <a:ea typeface="Inter"/>
+                <a:cs typeface="Inter"/>
+              </a:defRPr>
+            </a:lvl6pPr>
+            <a:lvl7pPr>
+              <a:defRPr sz="2025" b="1">
+                <a:solidFill>
+                  <a:srgbClr val="14221A"/>
+                </a:solidFill>
+                <a:latin typeface="Inter"/>
+                <a:ea typeface="Inter"/>
+                <a:cs typeface="Inter"/>
+              </a:defRPr>
+            </a:lvl7pPr>
+            <a:lvl8pPr>
+              <a:defRPr sz="2025" b="1">
+                <a:solidFill>
+                  <a:srgbClr val="14221A"/>
+                </a:solidFill>
+                <a:latin typeface="Inter"/>
+                <a:ea typeface="Inter"/>
+                <a:cs typeface="Inter"/>
+              </a:defRPr>
+            </a:lvl8pPr>
+            <a:lvl9pPr>
+              <a:defRPr sz="2025" b="1">
+                <a:solidFill>
+                  <a:srgbClr val="14221A"/>
+                </a:solidFill>
+                <a:latin typeface="Inter"/>
+                <a:ea typeface="Inter"/>
+                <a:cs typeface="Inter"/>
+              </a:defRPr>
+            </a:lvl9pPr>
+          </a:lstStyle>
+          <a:p xmlns:a="http://schemas.openxmlformats.org/drawingml/2006/main">
+            <a:pPr>
+              <a:defRPr sz="2025" b="1">
+                <a:solidFill>
+                  <a:srgbClr val="14221A"/>
+                </a:solidFill>
+                <a:latin typeface="Inter"/>
+                <a:ea typeface="Inter"/>
+                <a:cs typeface="Inter"/>
+              </a:defRPr>
+            </a:pPr>
+            <a:r>
+              <a:rPr sz="2025" b="1">
+                <a:solidFill>
+                  <a:srgbClr val="14221A"/>
+                </a:solidFill>
+                <a:latin typeface="Inter"/>
+                <a:ea typeface="Inter"/>
+                <a:cs typeface="Inter"/>
+              </a:rPr>
+              <a:t>associations verified</a:t>
+            </a:r>
+          </a:p>
+        </p:txBody>
+      </p:sp>
+      <p:sp>
+        <p:nvSpPr>
+          <p:cNvPr id="12" name="text-75">
+            <a:extLst xmlns:a="http://schemas.openxmlformats.org/drawingml/2006/main">
+              <a:ext uri="{FF2B5EF4-FFF2-40B4-BE49-F238E27FC236}">
+                <a16:creationId xmlns:a16="http://schemas.microsoft.com/office/drawing/2014/main" id="{9E436B4B-B300-469C-8560-AB0DB1F09498}"/>
+              </a:ext>
+            </a:extLst>
+          </p:cNvPr>
+          <p:cNvSpPr>
+            <a:spLocks xmlns:a="http://schemas.openxmlformats.org/drawingml/2006/main" noGrp="1"/>
+          </p:cNvSpPr>
+          <p:nvPr/>
+        </p:nvSpPr>
+        <p:spPr>
+          <a:xfrm xmlns:a="http://schemas.openxmlformats.org/drawingml/2006/main">
+            <a:off x="7162800" y="4143375"/>
+            <a:ext cx="4267200" cy="333375"/>
+          </a:xfrm>
+          <a:prstGeom xmlns:a="http://schemas.openxmlformats.org/drawingml/2006/main" prst="rect">
+            <a:avLst/>
+          </a:prstGeom>
+          <a:noFill xmlns:a="http://schemas.openxmlformats.org/drawingml/2006/main"/>
+          <a:ln xmlns:a="http://schemas.openxmlformats.org/drawingml/2006/main" w="0">
+            <a:noFill/>
+          </a:ln>
+        </p:spPr>
+        <p:txBody>
+          <a:bodyPr xmlns:a="http://schemas.openxmlformats.org/drawingml/2006/main" wrap="square" lIns="0" tIns="0" rIns="0" bIns="0">
+            <a:noAutofit/>
+          </a:bodyPr>
+          <a:lstStyle xmlns:a="http://schemas.openxmlformats.org/drawingml/2006/main">
+            <a:defPPr>
+              <a:defRPr sz="1650" b="0">
+                <a:solidFill>
+                  <a:srgbClr val="657167"/>
+                </a:solidFill>
+                <a:latin typeface="Inter"/>
+                <a:ea typeface="Inter"/>
+                <a:cs typeface="Inter"/>
+              </a:defRPr>
+            </a:defPPr>
+            <a:lvl1pPr>
+              <a:defRPr sz="1650" b="0">
+                <a:solidFill>
+                  <a:srgbClr val="657167"/>
+                </a:solidFill>
+                <a:latin typeface="Inter"/>
+                <a:ea typeface="Inter"/>
+                <a:cs typeface="Inter"/>
+              </a:defRPr>
+            </a:lvl1pPr>
+            <a:lvl2pPr>
+              <a:defRPr sz="1650" b="0">
+                <a:solidFill>
+                  <a:srgbClr val="657167"/>
+                </a:solidFill>
+                <a:latin typeface="Inter"/>
+                <a:ea typeface="Inter"/>
+                <a:cs typeface="Inter"/>
+              </a:defRPr>
+            </a:lvl2pPr>
+            <a:lvl3pPr>
+              <a:defRPr sz="1650" b="0">
+                <a:solidFill>
+                  <a:srgbClr val="657167"/>
+                </a:solidFill>
+                <a:latin typeface="Inter"/>
+                <a:ea typeface="Inter"/>
+                <a:cs typeface="Inter"/>
+              </a:defRPr>
+            </a:lvl3pPr>
+            <a:lvl4pPr>
+              <a:defRPr sz="1650" b="0">
+                <a:solidFill>
+                  <a:srgbClr val="657167"/>
+                </a:solidFill>
+                <a:latin typeface="Inter"/>
+                <a:ea typeface="Inter"/>
+                <a:cs typeface="Inter"/>
+              </a:defRPr>
+            </a:lvl4pPr>
+            <a:lvl5pPr>
+              <a:defRPr sz="1650" b="0">
+                <a:solidFill>
+                  <a:srgbClr val="657167"/>
+                </a:solidFill>
+                <a:latin typeface="Inter"/>
+                <a:ea typeface="Inter"/>
+                <a:cs typeface="Inter"/>
+              </a:defRPr>
+            </a:lvl5pPr>
+            <a:lvl6pPr>
+              <a:defRPr sz="1650" b="0">
+                <a:solidFill>
+                  <a:srgbClr val="657167"/>
+                </a:solidFill>
+                <a:latin typeface="Inter"/>
+                <a:ea typeface="Inter"/>
+                <a:cs typeface="Inter"/>
+              </a:defRPr>
+            </a:lvl6pPr>
+            <a:lvl7pPr>
+              <a:defRPr sz="1650" b="0">
+                <a:solidFill>
+                  <a:srgbClr val="657167"/>
+                </a:solidFill>
+                <a:latin typeface="Inter"/>
+                <a:ea typeface="Inter"/>
+                <a:cs typeface="Inter"/>
+              </a:defRPr>
+            </a:lvl7pPr>
+            <a:lvl8pPr>
+              <a:defRPr sz="1650" b="0">
+                <a:solidFill>
+                  <a:srgbClr val="657167"/>
+                </a:solidFill>
+                <a:latin typeface="Inter"/>
+                <a:ea typeface="Inter"/>
+                <a:cs typeface="Inter"/>
+              </a:defRPr>
+            </a:lvl8pPr>
+            <a:lvl9pPr>
+              <a:defRPr sz="1650" b="0">
+                <a:solidFill>
+                  <a:srgbClr val="657167"/>
+                </a:solidFill>
+                <a:latin typeface="Inter"/>
+                <a:ea typeface="Inter"/>
+                <a:cs typeface="Inter"/>
+              </a:defRPr>
+            </a:lvl9pPr>
+          </a:lstStyle>
+          <a:p xmlns:a="http://schemas.openxmlformats.org/drawingml/2006/main">
+            <a:pPr>
+              <a:defRPr sz="1650" b="0">
+                <a:solidFill>
+                  <a:srgbClr val="657167"/>
+                </a:solidFill>
+                <a:latin typeface="Inter"/>
+                <a:ea typeface="Inter"/>
+                <a:cs typeface="Inter"/>
+              </a:defRPr>
+            </a:pPr>
+            <a:r>
+              <a:rPr sz="1650" b="0">
+                <a:solidFill>
+                  <a:srgbClr val="657167"/>
+                </a:solidFill>
+                <a:latin typeface="Inter"/>
+                <a:ea typeface="Inter"/>
+                <a:cs typeface="Inter"/>
+              </a:rPr>
+              <a:t>41 genes · 9 root cell types</a:t>
+            </a:r>
+          </a:p>
+        </p:txBody>
+      </p:sp>
+      <p:sp>
+        <p:nvSpPr>
+          <p:cNvPr id="13" name="text-76">
+            <a:extLst xmlns:a="http://schemas.openxmlformats.org/drawingml/2006/main">
+              <a:ext uri="{FF2B5EF4-FFF2-40B4-BE49-F238E27FC236}">
+                <a16:creationId xmlns:a16="http://schemas.microsoft.com/office/drawing/2014/main" id="{5B2364AB-1A01-4A26-A6FC-A9783BF98111}"/>
+              </a:ext>
+            </a:extLst>
+          </p:cNvPr>
+          <p:cNvSpPr>
+            <a:spLocks xmlns:a="http://schemas.openxmlformats.org/drawingml/2006/main" noGrp="1"/>
+          </p:cNvSpPr>
+          <p:nvPr/>
+        </p:nvSpPr>
+        <p:spPr>
+          <a:xfrm xmlns:a="http://schemas.openxmlformats.org/drawingml/2006/main">
+            <a:off x="7162800" y="4591050"/>
+            <a:ext cx="4267200" cy="333375"/>
+          </a:xfrm>
+          <a:prstGeom xmlns:a="http://schemas.openxmlformats.org/drawingml/2006/main" prst="rect">
+            <a:avLst/>
+          </a:prstGeom>
+          <a:noFill xmlns:a="http://schemas.openxmlformats.org/drawingml/2006/main"/>
+          <a:ln xmlns:a="http://schemas.openxmlformats.org/drawingml/2006/main" w="0">
+            <a:noFill/>
+          </a:ln>
+        </p:spPr>
+        <p:txBody>
+          <a:bodyPr xmlns:a="http://schemas.openxmlformats.org/drawingml/2006/main" wrap="square" lIns="0" tIns="0" rIns="0" bIns="0">
+            <a:noAutofit/>
+          </a:bodyPr>
+          <a:lstStyle xmlns:a="http://schemas.openxmlformats.org/drawingml/2006/main">
+            <a:defPPr>
+              <a:defRPr sz="1575" b="1">
+                <a:solidFill>
+                  <a:srgbClr val="1B5E20"/>
+                </a:solidFill>
+                <a:latin typeface="Inter"/>
+                <a:ea typeface="Inter"/>
+                <a:cs typeface="Inter"/>
+              </a:defRPr>
+            </a:defPPr>
+            <a:lvl1pPr>
+              <a:defRPr sz="1575" b="1">
+                <a:solidFill>
+                  <a:srgbClr val="1B5E20"/>
+                </a:solidFill>
+                <a:latin typeface="Inter"/>
+                <a:ea typeface="Inter"/>
+                <a:cs typeface="Inter"/>
+              </a:defRPr>
+            </a:lvl1pPr>
+            <a:lvl2pPr>
+              <a:defRPr sz="1575" b="1">
+                <a:solidFill>
+                  <a:srgbClr val="1B5E20"/>
+                </a:solidFill>
+                <a:latin typeface="Inter"/>
+                <a:ea typeface="Inter"/>
+                <a:cs typeface="Inter"/>
+              </a:defRPr>
+            </a:lvl2pPr>
+            <a:lvl3pPr>
+              <a:defRPr sz="1575" b="1">
+                <a:solidFill>
+                  <a:srgbClr val="1B5E20"/>
+                </a:solidFill>
+                <a:latin typeface="Inter"/>
+                <a:ea typeface="Inter"/>
+                <a:cs typeface="Inter"/>
+              </a:defRPr>
+            </a:lvl3pPr>
+            <a:lvl4pPr>
+              <a:defRPr sz="1575" b="1">
+                <a:solidFill>
+                  <a:srgbClr val="1B5E20"/>
+                </a:solidFill>
+                <a:latin typeface="Inter"/>
+                <a:ea typeface="Inter"/>
+                <a:cs typeface="Inter"/>
+              </a:defRPr>
+            </a:lvl4pPr>
+            <a:lvl5pPr>
+              <a:defRPr sz="1575" b="1">
+                <a:solidFill>
+                  <a:srgbClr val="1B5E20"/>
+                </a:solidFill>
+                <a:latin typeface="Inter"/>
+                <a:ea typeface="Inter"/>
+                <a:cs typeface="Inter"/>
+              </a:defRPr>
+            </a:lvl5pPr>
+            <a:lvl6pPr>
+              <a:defRPr sz="1575" b="1">
+                <a:solidFill>
+                  <a:srgbClr val="1B5E20"/>
+                </a:solidFill>
+                <a:latin typeface="Inter"/>
+                <a:ea typeface="Inter"/>
+                <a:cs typeface="Inter"/>
+              </a:defRPr>
+            </a:lvl6pPr>
+            <a:lvl7pPr>
+              <a:defRPr sz="1575" b="1">
+                <a:solidFill>
+                  <a:srgbClr val="1B5E20"/>
+                </a:solidFill>
+                <a:latin typeface="Inter"/>
+                <a:ea typeface="Inter"/>
+                <a:cs typeface="Inter"/>
+              </a:defRPr>
+            </a:lvl7pPr>
+            <a:lvl8pPr>
+              <a:defRPr sz="1575" b="1">
+                <a:solidFill>
+                  <a:srgbClr val="1B5E20"/>
+                </a:solidFill>
+                <a:latin typeface="Inter"/>
+                <a:ea typeface="Inter"/>
+                <a:cs typeface="Inter"/>
+              </a:defRPr>
+            </a:lvl8pPr>
+            <a:lvl9pPr>
+              <a:defRPr sz="1575" b="1">
+                <a:solidFill>
+                  <a:srgbClr val="1B5E20"/>
+                </a:solidFill>
+                <a:latin typeface="Inter"/>
+                <a:ea typeface="Inter"/>
+                <a:cs typeface="Inter"/>
+              </a:defRPr>
+            </a:lvl9pPr>
+          </a:lstStyle>
+          <a:p xmlns:a="http://schemas.openxmlformats.org/drawingml/2006/main">
+            <a:pPr>
+              <a:defRPr sz="1575" b="1">
+                <a:solidFill>
+                  <a:srgbClr val="1B5E20"/>
+                </a:solidFill>
+                <a:latin typeface="Inter"/>
+                <a:ea typeface="Inter"/>
+                <a:cs typeface="Inter"/>
+              </a:defRPr>
+            </a:pPr>
+            <a:r>
+              <a:rPr sz="1575" b="1">
+                <a:solidFill>
+                  <a:srgbClr val="1B5E20"/>
+                </a:solidFill>
+                <a:latin typeface="Inter"/>
+                <a:ea typeface="Inter"/>
+                <a:cs typeface="Inter"/>
+              </a:rPr>
+              <a:t>Annotation stops if verification fails.</a:t>
             </a:r>
           </a:p>
         </p:txBody>
       </p:sp>
       <p:pic>
         <p:nvPicPr>
-          <p:cNvPr id="10" name="">
+          <p:cNvPr id="14" name="">
             <a:extLst xmlns:a="http://schemas.openxmlformats.org/drawingml/2006/main">
               <a:ext uri="{FF2B5EF4-FFF2-40B4-BE49-F238E27FC236}">
-                <a16:creationId xmlns:a16="http://schemas.microsoft.com/office/drawing/2014/main" id="{15C6ED60-B266-4AE2-BEB5-F48A7BABCF8E}"/>
+                <a16:creationId xmlns:a16="http://schemas.microsoft.com/office/drawing/2014/main" id="{5DE23A51-9F07-4608-9EE6-D74116F50E79}"/>
               </a:ext>
             </a:extLst>
           </p:cNvPr>
@@ -13756,14 +14260,14 @@
           <p:nvPr/>
         </p:nvPicPr>
         <p:blipFill>
-          <a:blip xmlns:r="http://schemas.openxmlformats.org/officeDocument/2006/relationships" xmlns:a="http://schemas.openxmlformats.org/drawingml/2006/main" r:embed="R0945869167234e39"/>
-          <a:srcRect xmlns:a="http://schemas.openxmlformats.org/drawingml/2006/main" l="25600" t="12500" r="26400" b="23000"/>
+          <a:blip xmlns:r="http://schemas.openxmlformats.org/officeDocument/2006/relationships" xmlns:a="http://schemas.openxmlformats.org/drawingml/2006/main" r:embed="R7430127c3ab64649"/>
+          <a:srcRect xmlns:a="http://schemas.openxmlformats.org/drawingml/2006/main" l="25600" t="13200" r="26400" b="80200"/>
           <a:stretch xmlns:a="http://schemas.openxmlformats.org/drawingml/2006/main"/>
         </p:blipFill>
         <p:spPr>
           <a:xfrm xmlns:a="http://schemas.openxmlformats.org/drawingml/2006/main">
-            <a:off x="7143750" y="2076450"/>
-            <a:ext cx="4086225" cy="3810000"/>
+            <a:off x="552450" y="5181600"/>
+            <a:ext cx="11106150" cy="1066800"/>
           </a:xfrm>
           <a:prstGeom xmlns:a="http://schemas.openxmlformats.org/drawingml/2006/main" prst="rect">
             <a:avLst/>
@@ -13773,7 +14277,7 @@
     </p:spTree>
     <p:extLst>
       <p:ext uri="{BB962C8B-B14F-4D97-AF65-F5344CB8AC3E}">
-        <p14:creationId xmlns:p14="http://schemas.microsoft.com/office/powerpoint/2010/main" val="1690029874"/>
+        <p14:creationId xmlns:p14="http://schemas.microsoft.com/office/powerpoint/2010/main" val="1766938367"/>
       </p:ext>
     </p:extLst>
   </p:cSld>
@@ -13801,10 +14305,10 @@
       </p:grpSpPr>
       <p:sp>
         <p:nvSpPr>
-          <p:cNvPr id="20" name="text-73">
+          <p:cNvPr id="20" name="text-77">
             <a:extLst xmlns:a="http://schemas.openxmlformats.org/drawingml/2006/main">
               <a:ext uri="{FF2B5EF4-FFF2-40B4-BE49-F238E27FC236}">
-                <a16:creationId xmlns:a16="http://schemas.microsoft.com/office/drawing/2014/main" id="{7A336C69-459E-41A1-9A7A-B3A4E7DA77C2}"/>
+                <a16:creationId xmlns:a16="http://schemas.microsoft.com/office/drawing/2014/main" id="{82AC2A63-8499-4FE6-8A71-C8DBBAE4B3A4}"/>
               </a:ext>
             </a:extLst>
           </p:cNvPr>
@@ -13959,10 +14463,10 @@
       </p:sp>
       <p:sp>
         <p:nvSpPr>
-          <p:cNvPr id="2" name="text-74">
+          <p:cNvPr id="2" name="text-78">
             <a:extLst xmlns:a="http://schemas.openxmlformats.org/drawingml/2006/main">
               <a:ext uri="{FF2B5EF4-FFF2-40B4-BE49-F238E27FC236}">
-                <a16:creationId xmlns:a16="http://schemas.microsoft.com/office/drawing/2014/main" id="{958F00FC-5E75-4394-8A29-8ADDD4E88CB1}"/>
+                <a16:creationId xmlns:a16="http://schemas.microsoft.com/office/drawing/2014/main" id="{66D997BD-E0F0-47C4-8A5A-AF59FEA0FD2A}"/>
               </a:ext>
             </a:extLst>
           </p:cNvPr>
@@ -14117,10 +14621,10 @@
       </p:sp>
       <p:sp>
         <p:nvSpPr>
-          <p:cNvPr id="3" name="text-75">
+          <p:cNvPr id="3" name="text-79">
             <a:extLst xmlns:a="http://schemas.openxmlformats.org/drawingml/2006/main">
               <a:ext uri="{FF2B5EF4-FFF2-40B4-BE49-F238E27FC236}">
-                <a16:creationId xmlns:a16="http://schemas.microsoft.com/office/drawing/2014/main" id="{3D625BD9-A3AF-4409-8BBA-888F34A3D497}"/>
+                <a16:creationId xmlns:a16="http://schemas.microsoft.com/office/drawing/2014/main" id="{2A119ACF-C13F-4DC7-B242-97D6D8D28549}"/>
               </a:ext>
             </a:extLst>
           </p:cNvPr>
@@ -14275,10 +14779,10 @@
       </p:sp>
       <p:sp>
         <p:nvSpPr>
-          <p:cNvPr id="4" name="text-76">
+          <p:cNvPr id="4" name="text-80">
             <a:extLst xmlns:a="http://schemas.openxmlformats.org/drawingml/2006/main">
               <a:ext uri="{FF2B5EF4-FFF2-40B4-BE49-F238E27FC236}">
-                <a16:creationId xmlns:a16="http://schemas.microsoft.com/office/drawing/2014/main" id="{FD8AEBF7-2B0B-47C1-A196-7D2544925F56}"/>
+                <a16:creationId xmlns:a16="http://schemas.microsoft.com/office/drawing/2014/main" id="{35CF9AA4-7624-43AF-9327-FF2E54FAC998}"/>
               </a:ext>
             </a:extLst>
           </p:cNvPr>
@@ -14433,10 +14937,10 @@
       </p:sp>
       <p:sp>
         <p:nvSpPr>
-          <p:cNvPr id="5" name="text-77">
+          <p:cNvPr id="5" name="text-81">
             <a:extLst xmlns:a="http://schemas.openxmlformats.org/drawingml/2006/main">
               <a:ext uri="{FF2B5EF4-FFF2-40B4-BE49-F238E27FC236}">
-                <a16:creationId xmlns:a16="http://schemas.microsoft.com/office/drawing/2014/main" id="{5EDD307F-7153-4B40-8CEF-9667B5F481CB}"/>
+                <a16:creationId xmlns:a16="http://schemas.microsoft.com/office/drawing/2014/main" id="{A2CBF47D-9B1F-45C9-9E6E-F05ACC457EA2}"/>
               </a:ext>
             </a:extLst>
           </p:cNvPr>
@@ -14591,10 +15095,10 @@
       </p:sp>
       <p:sp>
         <p:nvSpPr>
-          <p:cNvPr id="6" name="text-78">
+          <p:cNvPr id="6" name="text-82">
             <a:extLst xmlns:a="http://schemas.openxmlformats.org/drawingml/2006/main">
               <a:ext uri="{FF2B5EF4-FFF2-40B4-BE49-F238E27FC236}">
-                <a16:creationId xmlns:a16="http://schemas.microsoft.com/office/drawing/2014/main" id="{4F9E9604-BA5D-4DCE-92E2-4A4E9C599888}"/>
+                <a16:creationId xmlns:a16="http://schemas.microsoft.com/office/drawing/2014/main" id="{C341C604-3FF0-4AE8-BDC4-700ECE4D4F9B}"/>
               </a:ext>
             </a:extLst>
           </p:cNvPr>
@@ -14749,10 +15253,10 @@
       </p:sp>
       <p:sp>
         <p:nvSpPr>
-          <p:cNvPr id="7" name="text-79">
+          <p:cNvPr id="7" name="text-83">
             <a:extLst xmlns:a="http://schemas.openxmlformats.org/drawingml/2006/main">
               <a:ext uri="{FF2B5EF4-FFF2-40B4-BE49-F238E27FC236}">
-                <a16:creationId xmlns:a16="http://schemas.microsoft.com/office/drawing/2014/main" id="{EF80B33E-85E1-4039-B6B7-B4C4C74C0741}"/>
+                <a16:creationId xmlns:a16="http://schemas.microsoft.com/office/drawing/2014/main" id="{D78B9786-F2D6-421F-999F-8DAE2AA6FFB0}"/>
               </a:ext>
             </a:extLst>
           </p:cNvPr>
@@ -14907,10 +15411,10 @@
       </p:sp>
       <p:sp>
         <p:nvSpPr>
-          <p:cNvPr id="8" name="text-80">
+          <p:cNvPr id="8" name="text-84">
             <a:extLst xmlns:a="http://schemas.openxmlformats.org/drawingml/2006/main">
               <a:ext uri="{FF2B5EF4-FFF2-40B4-BE49-F238E27FC236}">
-                <a16:creationId xmlns:a16="http://schemas.microsoft.com/office/drawing/2014/main" id="{9D69E0C2-31ED-4B91-AC06-6C481941F85F}"/>
+                <a16:creationId xmlns:a16="http://schemas.microsoft.com/office/drawing/2014/main" id="{C1C8C00E-F51A-4416-8EE0-783DBD4ABA86}"/>
               </a:ext>
             </a:extLst>
           </p:cNvPr>
@@ -15065,10 +15569,10 @@
       </p:sp>
       <p:sp>
         <p:nvSpPr>
-          <p:cNvPr id="9" name="text-81">
+          <p:cNvPr id="9" name="text-85">
             <a:extLst xmlns:a="http://schemas.openxmlformats.org/drawingml/2006/main">
               <a:ext uri="{FF2B5EF4-FFF2-40B4-BE49-F238E27FC236}">
-                <a16:creationId xmlns:a16="http://schemas.microsoft.com/office/drawing/2014/main" id="{1B92A71B-3219-48D6-BF31-4BE74D7F8F3B}"/>
+                <a16:creationId xmlns:a16="http://schemas.microsoft.com/office/drawing/2014/main" id="{845C02DA-BB3C-4A39-AF2E-70141A4091FD}"/>
               </a:ext>
             </a:extLst>
           </p:cNvPr>
@@ -15223,10 +15727,10 @@
       </p:sp>
       <p:sp>
         <p:nvSpPr>
-          <p:cNvPr id="10" name="text-82">
+          <p:cNvPr id="10" name="text-86">
             <a:extLst xmlns:a="http://schemas.openxmlformats.org/drawingml/2006/main">
               <a:ext uri="{FF2B5EF4-FFF2-40B4-BE49-F238E27FC236}">
-                <a16:creationId xmlns:a16="http://schemas.microsoft.com/office/drawing/2014/main" id="{9B2481C8-FE49-4AC7-9DA9-89561CE5EB05}"/>
+                <a16:creationId xmlns:a16="http://schemas.microsoft.com/office/drawing/2014/main" id="{9FB885B7-829A-4124-82EB-7E791095620B}"/>
               </a:ext>
             </a:extLst>
           </p:cNvPr>
@@ -15381,10 +15885,10 @@
       </p:sp>
       <p:sp>
         <p:nvSpPr>
-          <p:cNvPr id="11" name="text-83">
+          <p:cNvPr id="11" name="text-87">
             <a:extLst xmlns:a="http://schemas.openxmlformats.org/drawingml/2006/main">
               <a:ext uri="{FF2B5EF4-FFF2-40B4-BE49-F238E27FC236}">
-                <a16:creationId xmlns:a16="http://schemas.microsoft.com/office/drawing/2014/main" id="{ED202CD5-2704-45F8-93E8-71D81E8A2C51}"/>
+                <a16:creationId xmlns:a16="http://schemas.microsoft.com/office/drawing/2014/main" id="{5B11B9B4-6CD3-4775-86F3-36CAEF293E5D}"/>
               </a:ext>
             </a:extLst>
           </p:cNvPr>
@@ -15539,10 +16043,10 @@
       </p:sp>
       <p:sp>
         <p:nvSpPr>
-          <p:cNvPr id="12" name="text-84">
+          <p:cNvPr id="12" name="text-88">
             <a:extLst xmlns:a="http://schemas.openxmlformats.org/drawingml/2006/main">
               <a:ext uri="{FF2B5EF4-FFF2-40B4-BE49-F238E27FC236}">
-                <a16:creationId xmlns:a16="http://schemas.microsoft.com/office/drawing/2014/main" id="{FE13EB3B-E59B-4B51-ACDB-17A23F7822DF}"/>
+                <a16:creationId xmlns:a16="http://schemas.microsoft.com/office/drawing/2014/main" id="{3B28A372-AA53-4740-ACB2-7916A89D8CC4}"/>
               </a:ext>
             </a:extLst>
           </p:cNvPr>
@@ -15697,10 +16201,10 @@
       </p:sp>
       <p:sp>
         <p:nvSpPr>
-          <p:cNvPr id="13" name="text-85">
+          <p:cNvPr id="13" name="text-89">
             <a:extLst xmlns:a="http://schemas.openxmlformats.org/drawingml/2006/main">
               <a:ext uri="{FF2B5EF4-FFF2-40B4-BE49-F238E27FC236}">
-                <a16:creationId xmlns:a16="http://schemas.microsoft.com/office/drawing/2014/main" id="{B9285C3A-F5D6-4E91-ABB1-818BAD9F8AF9}"/>
+                <a16:creationId xmlns:a16="http://schemas.microsoft.com/office/drawing/2014/main" id="{27DE9A62-2E20-486E-9425-88AB351E5B15}"/>
               </a:ext>
             </a:extLst>
           </p:cNvPr>
@@ -15855,10 +16359,10 @@
       </p:sp>
       <p:sp>
         <p:nvSpPr>
-          <p:cNvPr id="14" name="text-86">
+          <p:cNvPr id="14" name="text-90">
             <a:extLst xmlns:a="http://schemas.openxmlformats.org/drawingml/2006/main">
               <a:ext uri="{FF2B5EF4-FFF2-40B4-BE49-F238E27FC236}">
-                <a16:creationId xmlns:a16="http://schemas.microsoft.com/office/drawing/2014/main" id="{A96AB278-65EE-42A7-80FD-2EE5F821B9D0}"/>
+                <a16:creationId xmlns:a16="http://schemas.microsoft.com/office/drawing/2014/main" id="{BEF77517-7C84-48CE-A22D-13594A518BEA}"/>
               </a:ext>
             </a:extLst>
           </p:cNvPr>
@@ -16013,10 +16517,10 @@
       </p:sp>
       <p:sp>
         <p:nvSpPr>
-          <p:cNvPr id="15" name="text-87">
+          <p:cNvPr id="15" name="text-91">
             <a:extLst xmlns:a="http://schemas.openxmlformats.org/drawingml/2006/main">
               <a:ext uri="{FF2B5EF4-FFF2-40B4-BE49-F238E27FC236}">
-                <a16:creationId xmlns:a16="http://schemas.microsoft.com/office/drawing/2014/main" id="{C2B96EDE-7D13-48A0-8727-C80FD72A2289}"/>
+                <a16:creationId xmlns:a16="http://schemas.microsoft.com/office/drawing/2014/main" id="{7BE93170-4A45-437E-922D-D6A8EE0AA342}"/>
               </a:ext>
             </a:extLst>
           </p:cNvPr>
@@ -16171,10 +16675,10 @@
       </p:sp>
       <p:sp>
         <p:nvSpPr>
-          <p:cNvPr id="16" name="text-88">
+          <p:cNvPr id="16" name="text-92">
             <a:extLst xmlns:a="http://schemas.openxmlformats.org/drawingml/2006/main">
               <a:ext uri="{FF2B5EF4-FFF2-40B4-BE49-F238E27FC236}">
-                <a16:creationId xmlns:a16="http://schemas.microsoft.com/office/drawing/2014/main" id="{78B83B7E-4C7C-431C-841F-0CCEA77627F0}"/>
+                <a16:creationId xmlns:a16="http://schemas.microsoft.com/office/drawing/2014/main" id="{43D98265-37C2-4EA9-92E3-8B6A12811002}"/>
               </a:ext>
             </a:extLst>
           </p:cNvPr>
@@ -16329,10 +16833,10 @@
       </p:sp>
       <p:sp>
         <p:nvSpPr>
-          <p:cNvPr id="17" name="text-89">
+          <p:cNvPr id="17" name="text-93">
             <a:extLst xmlns:a="http://schemas.openxmlformats.org/drawingml/2006/main">
               <a:ext uri="{FF2B5EF4-FFF2-40B4-BE49-F238E27FC236}">
-                <a16:creationId xmlns:a16="http://schemas.microsoft.com/office/drawing/2014/main" id="{C2AB63E7-25C2-4F56-9ED1-14E6DCB64316}"/>
+                <a16:creationId xmlns:a16="http://schemas.microsoft.com/office/drawing/2014/main" id="{1E127313-02A7-4042-B026-720D40D07AB7}"/>
               </a:ext>
             </a:extLst>
           </p:cNvPr>
@@ -16490,7 +16994,7 @@
           <p:cNvPr id="18" name="">
             <a:extLst xmlns:a="http://schemas.openxmlformats.org/drawingml/2006/main">
               <a:ext uri="{FF2B5EF4-FFF2-40B4-BE49-F238E27FC236}">
-                <a16:creationId xmlns:a16="http://schemas.microsoft.com/office/drawing/2014/main" id="{6FF05C09-D28F-41B5-AFD2-FC110140B070}"/>
+                <a16:creationId xmlns:a16="http://schemas.microsoft.com/office/drawing/2014/main" id="{E334EFC6-AC55-4891-89C5-896FC39EB5A9}"/>
               </a:ext>
             </a:extLst>
           </p:cNvPr>
@@ -16500,7 +17004,7 @@
           <p:nvPr/>
         </p:nvPicPr>
         <p:blipFill>
-          <a:blip xmlns:r="http://schemas.openxmlformats.org/officeDocument/2006/relationships" xmlns:a="http://schemas.openxmlformats.org/drawingml/2006/main" r:embed="R343955ef6098415c"/>
+          <a:blip xmlns:r="http://schemas.openxmlformats.org/officeDocument/2006/relationships" xmlns:a="http://schemas.openxmlformats.org/drawingml/2006/main" r:embed="Rf866231911a54fec"/>
           <a:stretch xmlns:a="http://schemas.openxmlformats.org/drawingml/2006/main"/>
         </p:blipFill>
         <p:spPr>
@@ -16515,10 +17019,10 @@
       </p:pic>
       <p:sp>
         <p:nvSpPr>
-          <p:cNvPr id="19" name="text-90">
+          <p:cNvPr id="19" name="text-94">
             <a:extLst xmlns:a="http://schemas.openxmlformats.org/drawingml/2006/main">
               <a:ext uri="{FF2B5EF4-FFF2-40B4-BE49-F238E27FC236}">
-                <a16:creationId xmlns:a16="http://schemas.microsoft.com/office/drawing/2014/main" id="{76A6FC93-D18A-4ECB-AEEF-90359FEBED04}"/>
+                <a16:creationId xmlns:a16="http://schemas.microsoft.com/office/drawing/2014/main" id="{A481609F-1725-4B6A-AEE0-204C9C0E6403}"/>
               </a:ext>
             </a:extLst>
           </p:cNvPr>
@@ -16674,7 +17178,7 @@
     </p:spTree>
     <p:extLst>
       <p:ext uri="{BB962C8B-B14F-4D97-AF65-F5344CB8AC3E}">
-        <p14:creationId xmlns:p14="http://schemas.microsoft.com/office/powerpoint/2010/main" val="885957822"/>
+        <p14:creationId xmlns:p14="http://schemas.microsoft.com/office/powerpoint/2010/main" val="906232645"/>
       </p:ext>
     </p:extLst>
   </p:cSld>
@@ -16702,10 +17206,10 @@
       </p:grpSpPr>
       <p:sp>
         <p:nvSpPr>
-          <p:cNvPr id="16" name="text-91">
+          <p:cNvPr id="16" name="text-95">
             <a:extLst xmlns:a="http://schemas.openxmlformats.org/drawingml/2006/main">
               <a:ext uri="{FF2B5EF4-FFF2-40B4-BE49-F238E27FC236}">
-                <a16:creationId xmlns:a16="http://schemas.microsoft.com/office/drawing/2014/main" id="{6710512C-3B86-4AAA-A36D-ACCB0C10FB7B}"/>
+                <a16:creationId xmlns:a16="http://schemas.microsoft.com/office/drawing/2014/main" id="{676FB512-F0C1-41C0-BF09-CDDF1ECEB117}"/>
               </a:ext>
             </a:extLst>
           </p:cNvPr>
@@ -16860,10 +17364,10 @@
       </p:sp>
       <p:sp>
         <p:nvSpPr>
-          <p:cNvPr id="2" name="text-92">
+          <p:cNvPr id="2" name="text-96">
             <a:extLst xmlns:a="http://schemas.openxmlformats.org/drawingml/2006/main">
               <a:ext uri="{FF2B5EF4-FFF2-40B4-BE49-F238E27FC236}">
-                <a16:creationId xmlns:a16="http://schemas.microsoft.com/office/drawing/2014/main" id="{2ABFB100-6BA9-4EB0-8B38-AA14BF8A9EF1}"/>
+                <a16:creationId xmlns:a16="http://schemas.microsoft.com/office/drawing/2014/main" id="{1E53367D-86B3-4251-B56A-5158D9A330B1}"/>
               </a:ext>
             </a:extLst>
           </p:cNvPr>
@@ -17018,10 +17522,10 @@
       </p:sp>
       <p:sp>
         <p:nvSpPr>
-          <p:cNvPr id="3" name="text-93">
+          <p:cNvPr id="3" name="text-97">
             <a:extLst xmlns:a="http://schemas.openxmlformats.org/drawingml/2006/main">
               <a:ext uri="{FF2B5EF4-FFF2-40B4-BE49-F238E27FC236}">
-                <a16:creationId xmlns:a16="http://schemas.microsoft.com/office/drawing/2014/main" id="{C8EA4844-DA74-4B12-A59B-E0120757BB44}"/>
+                <a16:creationId xmlns:a16="http://schemas.microsoft.com/office/drawing/2014/main" id="{5D6978D6-B3EF-4462-BC1F-193A1C8D7226}"/>
               </a:ext>
             </a:extLst>
           </p:cNvPr>
@@ -17176,10 +17680,10 @@
       </p:sp>
       <p:sp>
         <p:nvSpPr>
-          <p:cNvPr id="4" name="text-94">
+          <p:cNvPr id="4" name="text-98">
             <a:extLst xmlns:a="http://schemas.openxmlformats.org/drawingml/2006/main">
               <a:ext uri="{FF2B5EF4-FFF2-40B4-BE49-F238E27FC236}">
-                <a16:creationId xmlns:a16="http://schemas.microsoft.com/office/drawing/2014/main" id="{C06FC85C-2AC7-4A61-A86F-B1E97FC74F98}"/>
+                <a16:creationId xmlns:a16="http://schemas.microsoft.com/office/drawing/2014/main" id="{C2EF8027-35B2-4DEF-BB47-E6FA7E81C91F}"/>
               </a:ext>
             </a:extLst>
           </p:cNvPr>
@@ -17334,10 +17838,10 @@
       </p:sp>
       <p:sp>
         <p:nvSpPr>
-          <p:cNvPr id="5" name="box-95">
+          <p:cNvPr id="5" name="box-99">
             <a:extLst xmlns:a="http://schemas.openxmlformats.org/drawingml/2006/main">
               <a:ext uri="{FF2B5EF4-FFF2-40B4-BE49-F238E27FC236}">
-                <a16:creationId xmlns:a16="http://schemas.microsoft.com/office/drawing/2014/main" id="{352F72DF-6B89-4DAB-9E2D-88B0962F7188}"/>
+                <a16:creationId xmlns:a16="http://schemas.microsoft.com/office/drawing/2014/main" id="{4C333AAD-19B2-4DC4-AF5C-CE6AC205B29E}"/>
               </a:ext>
             </a:extLst>
           </p:cNvPr>
@@ -17364,10 +17868,10 @@
       </p:sp>
       <p:sp>
         <p:nvSpPr>
-          <p:cNvPr id="6" name="text-96">
+          <p:cNvPr id="6" name="text-100">
             <a:extLst xmlns:a="http://schemas.openxmlformats.org/drawingml/2006/main">
               <a:ext uri="{FF2B5EF4-FFF2-40B4-BE49-F238E27FC236}">
-                <a16:creationId xmlns:a16="http://schemas.microsoft.com/office/drawing/2014/main" id="{A0ACEEF3-2597-4BDD-99A8-37305082FC25}"/>
+                <a16:creationId xmlns:a16="http://schemas.microsoft.com/office/drawing/2014/main" id="{4DD67483-302B-41B1-AFEE-5427322F14B8}"/>
               </a:ext>
             </a:extLst>
           </p:cNvPr>
@@ -17522,10 +18026,10 @@
       </p:sp>
       <p:sp>
         <p:nvSpPr>
-          <p:cNvPr id="7" name="text-97">
+          <p:cNvPr id="7" name="text-101">
             <a:extLst xmlns:a="http://schemas.openxmlformats.org/drawingml/2006/main">
               <a:ext uri="{FF2B5EF4-FFF2-40B4-BE49-F238E27FC236}">
-                <a16:creationId xmlns:a16="http://schemas.microsoft.com/office/drawing/2014/main" id="{6F3EA0FC-518E-4025-B39C-FFD8508E784B}"/>
+                <a16:creationId xmlns:a16="http://schemas.microsoft.com/office/drawing/2014/main" id="{9126CEB6-09E7-4915-ABED-A2728A7353BE}"/>
               </a:ext>
             </a:extLst>
           </p:cNvPr>
@@ -17680,10 +18184,10 @@
       </p:sp>
       <p:sp>
         <p:nvSpPr>
-          <p:cNvPr id="8" name="box-98">
+          <p:cNvPr id="8" name="box-102">
             <a:extLst xmlns:a="http://schemas.openxmlformats.org/drawingml/2006/main">
               <a:ext uri="{FF2B5EF4-FFF2-40B4-BE49-F238E27FC236}">
-                <a16:creationId xmlns:a16="http://schemas.microsoft.com/office/drawing/2014/main" id="{DFE0A1F9-C028-4536-9E49-FCE973636221}"/>
+                <a16:creationId xmlns:a16="http://schemas.microsoft.com/office/drawing/2014/main" id="{5CE5005F-E54D-4A91-8C8D-79F51BAC635C}"/>
               </a:ext>
             </a:extLst>
           </p:cNvPr>
@@ -17710,10 +18214,10 @@
       </p:sp>
       <p:sp>
         <p:nvSpPr>
-          <p:cNvPr id="9" name="text-99">
+          <p:cNvPr id="9" name="text-103">
             <a:extLst xmlns:a="http://schemas.openxmlformats.org/drawingml/2006/main">
               <a:ext uri="{FF2B5EF4-FFF2-40B4-BE49-F238E27FC236}">
-                <a16:creationId xmlns:a16="http://schemas.microsoft.com/office/drawing/2014/main" id="{6384D73F-F0ED-4E0F-9971-AD693C5BBA97}"/>
+                <a16:creationId xmlns:a16="http://schemas.microsoft.com/office/drawing/2014/main" id="{55516124-A4B1-4161-8800-DE30580275FC}"/>
               </a:ext>
             </a:extLst>
           </p:cNvPr>
@@ -17868,10 +18372,10 @@
       </p:sp>
       <p:sp>
         <p:nvSpPr>
-          <p:cNvPr id="10" name="text-100">
+          <p:cNvPr id="10" name="text-104">
             <a:extLst xmlns:a="http://schemas.openxmlformats.org/drawingml/2006/main">
               <a:ext uri="{FF2B5EF4-FFF2-40B4-BE49-F238E27FC236}">
-                <a16:creationId xmlns:a16="http://schemas.microsoft.com/office/drawing/2014/main" id="{6CABB174-32DB-4ADE-A38A-3B5378ECFDD3}"/>
+                <a16:creationId xmlns:a16="http://schemas.microsoft.com/office/drawing/2014/main" id="{B10EE9C5-A040-4344-9464-F47E054941E5}"/>
               </a:ext>
             </a:extLst>
           </p:cNvPr>
@@ -18026,10 +18530,10 @@
       </p:sp>
       <p:sp>
         <p:nvSpPr>
-          <p:cNvPr id="11" name="box-101">
+          <p:cNvPr id="11" name="box-105">
             <a:extLst xmlns:a="http://schemas.openxmlformats.org/drawingml/2006/main">
               <a:ext uri="{FF2B5EF4-FFF2-40B4-BE49-F238E27FC236}">
-                <a16:creationId xmlns:a16="http://schemas.microsoft.com/office/drawing/2014/main" id="{FD5B1C1F-AA82-4D82-B050-EB82319688FA}"/>
+                <a16:creationId xmlns:a16="http://schemas.microsoft.com/office/drawing/2014/main" id="{F6F5E5E8-7980-4BF8-AC27-719F035C52A3}"/>
               </a:ext>
             </a:extLst>
           </p:cNvPr>
@@ -18056,10 +18560,10 @@
       </p:sp>
       <p:sp>
         <p:nvSpPr>
-          <p:cNvPr id="12" name="text-102">
+          <p:cNvPr id="12" name="text-106">
             <a:extLst xmlns:a="http://schemas.openxmlformats.org/drawingml/2006/main">
               <a:ext uri="{FF2B5EF4-FFF2-40B4-BE49-F238E27FC236}">
-                <a16:creationId xmlns:a16="http://schemas.microsoft.com/office/drawing/2014/main" id="{9FFB5E0D-54AA-41E1-8D67-055EDC54207B}"/>
+                <a16:creationId xmlns:a16="http://schemas.microsoft.com/office/drawing/2014/main" id="{02220EE7-0E09-4FD1-B6A0-C8D054341C98}"/>
               </a:ext>
             </a:extLst>
           </p:cNvPr>
@@ -18214,10 +18718,10 @@
       </p:sp>
       <p:sp>
         <p:nvSpPr>
-          <p:cNvPr id="13" name="text-103">
+          <p:cNvPr id="13" name="text-107">
             <a:extLst xmlns:a="http://schemas.openxmlformats.org/drawingml/2006/main">
               <a:ext uri="{FF2B5EF4-FFF2-40B4-BE49-F238E27FC236}">
-                <a16:creationId xmlns:a16="http://schemas.microsoft.com/office/drawing/2014/main" id="{C1BDB28C-B9C9-483B-867A-29F913376447}"/>
+                <a16:creationId xmlns:a16="http://schemas.microsoft.com/office/drawing/2014/main" id="{60AD7B23-CCC5-441B-8E78-147A09E5679D}"/>
               </a:ext>
             </a:extLst>
           </p:cNvPr>
@@ -18375,7 +18879,7 @@
           <p:cNvPr id="14" name="">
             <a:extLst xmlns:a="http://schemas.openxmlformats.org/drawingml/2006/main">
               <a:ext uri="{FF2B5EF4-FFF2-40B4-BE49-F238E27FC236}">
-                <a16:creationId xmlns:a16="http://schemas.microsoft.com/office/drawing/2014/main" id="{3B0D65E5-0764-4A67-BD76-F0C7748DE854}"/>
+                <a16:creationId xmlns:a16="http://schemas.microsoft.com/office/drawing/2014/main" id="{C765E3CA-1B09-4E08-A6AE-2EC28221BEA9}"/>
               </a:ext>
             </a:extLst>
           </p:cNvPr>
@@ -18385,7 +18889,7 @@
           <p:nvPr/>
         </p:nvPicPr>
         <p:blipFill>
-          <a:blip xmlns:r="http://schemas.openxmlformats.org/officeDocument/2006/relationships" xmlns:a="http://schemas.openxmlformats.org/drawingml/2006/main" r:embed="Rb46eceaad69a439b"/>
+          <a:blip xmlns:r="http://schemas.openxmlformats.org/officeDocument/2006/relationships" xmlns:a="http://schemas.openxmlformats.org/drawingml/2006/main" r:embed="R47d4c79e42794e43"/>
           <a:srcRect xmlns:a="http://schemas.openxmlformats.org/drawingml/2006/main" l="25600" t="26800" r="26400" b="25000"/>
           <a:stretch xmlns:a="http://schemas.openxmlformats.org/drawingml/2006/main"/>
         </p:blipFill>
@@ -18401,10 +18905,10 @@
       </p:pic>
       <p:sp>
         <p:nvSpPr>
-          <p:cNvPr id="15" name="text-104">
+          <p:cNvPr id="15" name="text-108">
             <a:extLst xmlns:a="http://schemas.openxmlformats.org/drawingml/2006/main">
               <a:ext uri="{FF2B5EF4-FFF2-40B4-BE49-F238E27FC236}">
-                <a16:creationId xmlns:a16="http://schemas.microsoft.com/office/drawing/2014/main" id="{BB4E0F9C-E3BB-42CA-BA09-A4C17421AB50}"/>
+                <a16:creationId xmlns:a16="http://schemas.microsoft.com/office/drawing/2014/main" id="{BBDD91A2-0038-4F63-96B5-843D7E2195D5}"/>
               </a:ext>
             </a:extLst>
           </p:cNvPr>
@@ -18560,7 +19064,7 @@
     </p:spTree>
     <p:extLst>
       <p:ext uri="{BB962C8B-B14F-4D97-AF65-F5344CB8AC3E}">
-        <p14:creationId xmlns:p14="http://schemas.microsoft.com/office/powerpoint/2010/main" val="773496316"/>
+        <p14:creationId xmlns:p14="http://schemas.microsoft.com/office/powerpoint/2010/main" val="341694101"/>
       </p:ext>
     </p:extLst>
   </p:cSld>
@@ -18588,10 +19092,10 @@
       </p:grpSpPr>
       <p:sp>
         <p:nvSpPr>
-          <p:cNvPr id="7" name="text-105">
+          <p:cNvPr id="7" name="text-109">
             <a:extLst xmlns:a="http://schemas.openxmlformats.org/drawingml/2006/main">
               <a:ext uri="{FF2B5EF4-FFF2-40B4-BE49-F238E27FC236}">
-                <a16:creationId xmlns:a16="http://schemas.microsoft.com/office/drawing/2014/main" id="{03791D2F-79AF-4126-A99A-BD27608ABCB9}"/>
+                <a16:creationId xmlns:a16="http://schemas.microsoft.com/office/drawing/2014/main" id="{E1F52701-7523-4CDF-AEEA-CFA7E3BF50A6}"/>
               </a:ext>
             </a:extLst>
           </p:cNvPr>
@@ -18746,10 +19250,10 @@
       </p:sp>
       <p:sp>
         <p:nvSpPr>
-          <p:cNvPr id="2" name="text-106">
+          <p:cNvPr id="2" name="text-110">
             <a:extLst xmlns:a="http://schemas.openxmlformats.org/drawingml/2006/main">
               <a:ext uri="{FF2B5EF4-FFF2-40B4-BE49-F238E27FC236}">
-                <a16:creationId xmlns:a16="http://schemas.microsoft.com/office/drawing/2014/main" id="{4200F17A-03CB-4343-8106-5CF8F88A06B6}"/>
+                <a16:creationId xmlns:a16="http://schemas.microsoft.com/office/drawing/2014/main" id="{0F32D16B-E0B2-4AE8-A095-8E9386071F76}"/>
               </a:ext>
             </a:extLst>
           </p:cNvPr>
@@ -18904,10 +19408,10 @@
       </p:sp>
       <p:sp>
         <p:nvSpPr>
-          <p:cNvPr id="3" name="text-107">
+          <p:cNvPr id="3" name="text-111">
             <a:extLst xmlns:a="http://schemas.openxmlformats.org/drawingml/2006/main">
               <a:ext uri="{FF2B5EF4-FFF2-40B4-BE49-F238E27FC236}">
-                <a16:creationId xmlns:a16="http://schemas.microsoft.com/office/drawing/2014/main" id="{C91FB06B-7E23-4B63-A5C0-36C6D8E4A49E}"/>
+                <a16:creationId xmlns:a16="http://schemas.microsoft.com/office/drawing/2014/main" id="{CEB0117A-23E6-468E-80AD-C543BDBEC4CA}"/>
               </a:ext>
             </a:extLst>
           </p:cNvPr>
@@ -19062,10 +19566,10 @@
       </p:sp>
       <p:sp>
         <p:nvSpPr>
-          <p:cNvPr id="4" name="text-108">
+          <p:cNvPr id="4" name="text-112">
             <a:extLst xmlns:a="http://schemas.openxmlformats.org/drawingml/2006/main">
               <a:ext uri="{FF2B5EF4-FFF2-40B4-BE49-F238E27FC236}">
-                <a16:creationId xmlns:a16="http://schemas.microsoft.com/office/drawing/2014/main" id="{480B6A4B-FC5E-40F4-B5C6-A0538BAFBFEE}"/>
+                <a16:creationId xmlns:a16="http://schemas.microsoft.com/office/drawing/2014/main" id="{0529629A-54DB-47CB-9B7E-C64BF0C0ED3B}"/>
               </a:ext>
             </a:extLst>
           </p:cNvPr>
@@ -19223,7 +19727,7 @@
           <p:cNvPr id="5" name="">
             <a:extLst xmlns:a="http://schemas.openxmlformats.org/drawingml/2006/main">
               <a:ext uri="{FF2B5EF4-FFF2-40B4-BE49-F238E27FC236}">
-                <a16:creationId xmlns:a16="http://schemas.microsoft.com/office/drawing/2014/main" id="{B5688B9E-F754-4220-8DA2-D5F397E38F28}"/>
+                <a16:creationId xmlns:a16="http://schemas.microsoft.com/office/drawing/2014/main" id="{680AAFE9-91F5-4AF8-B6F2-DD3A88F2FA1A}"/>
               </a:ext>
             </a:extLst>
           </p:cNvPr>
@@ -19963,10 +20467,10 @@
       </p:graphicFrame>
       <p:sp>
         <p:nvSpPr>
-          <p:cNvPr id="6" name="text-109">
+          <p:cNvPr id="6" name="text-113">
             <a:extLst xmlns:a="http://schemas.openxmlformats.org/drawingml/2006/main">
               <a:ext uri="{FF2B5EF4-FFF2-40B4-BE49-F238E27FC236}">
-                <a16:creationId xmlns:a16="http://schemas.microsoft.com/office/drawing/2014/main" id="{795FB712-CDA0-4898-8583-D28FD42033D1}"/>
+                <a16:creationId xmlns:a16="http://schemas.microsoft.com/office/drawing/2014/main" id="{1447155D-DC2A-4C0E-91DD-1F41D64CBC34}"/>
               </a:ext>
             </a:extLst>
           </p:cNvPr>
@@ -20122,7 +20626,7 @@
     </p:spTree>
     <p:extLst>
       <p:ext uri="{BB962C8B-B14F-4D97-AF65-F5344CB8AC3E}">
-        <p14:creationId xmlns:p14="http://schemas.microsoft.com/office/powerpoint/2010/main" val="1346396564"/>
+        <p14:creationId xmlns:p14="http://schemas.microsoft.com/office/powerpoint/2010/main" val="447618161"/>
       </p:ext>
     </p:extLst>
   </p:cSld>
@@ -20150,10 +20654,10 @@
       </p:grpSpPr>
       <p:sp>
         <p:nvSpPr>
-          <p:cNvPr id="8" name="text-110">
+          <p:cNvPr id="8" name="text-114">
             <a:extLst xmlns:a="http://schemas.openxmlformats.org/drawingml/2006/main">
               <a:ext uri="{FF2B5EF4-FFF2-40B4-BE49-F238E27FC236}">
-                <a16:creationId xmlns:a16="http://schemas.microsoft.com/office/drawing/2014/main" id="{C142DC64-D8D3-4E04-A49D-2ADB21ED13D1}"/>
+                <a16:creationId xmlns:a16="http://schemas.microsoft.com/office/drawing/2014/main" id="{C6ABB45D-8B5A-4CFC-B8A7-3E0FD5543274}"/>
               </a:ext>
             </a:extLst>
           </p:cNvPr>
@@ -20308,10 +20812,10 @@
       </p:sp>
       <p:sp>
         <p:nvSpPr>
-          <p:cNvPr id="2" name="text-111">
+          <p:cNvPr id="2" name="text-115">
             <a:extLst xmlns:a="http://schemas.openxmlformats.org/drawingml/2006/main">
               <a:ext uri="{FF2B5EF4-FFF2-40B4-BE49-F238E27FC236}">
-                <a16:creationId xmlns:a16="http://schemas.microsoft.com/office/drawing/2014/main" id="{C10A72C8-D4BA-43BD-9F2F-3C0DDE2529B1}"/>
+                <a16:creationId xmlns:a16="http://schemas.microsoft.com/office/drawing/2014/main" id="{3017CCD1-80BA-473D-A04A-F94EE094D5E5}"/>
               </a:ext>
             </a:extLst>
           </p:cNvPr>
@@ -20466,10 +20970,10 @@
       </p:sp>
       <p:sp>
         <p:nvSpPr>
-          <p:cNvPr id="3" name="text-112">
+          <p:cNvPr id="3" name="text-116">
             <a:extLst xmlns:a="http://schemas.openxmlformats.org/drawingml/2006/main">
               <a:ext uri="{FF2B5EF4-FFF2-40B4-BE49-F238E27FC236}">
-                <a16:creationId xmlns:a16="http://schemas.microsoft.com/office/drawing/2014/main" id="{72DA62F2-014B-4F52-8E3B-D882B1A15656}"/>
+                <a16:creationId xmlns:a16="http://schemas.microsoft.com/office/drawing/2014/main" id="{D2D144D4-0543-494D-8D6A-8E13665D8CCE}"/>
               </a:ext>
             </a:extLst>
           </p:cNvPr>
@@ -20624,10 +21128,10 @@
       </p:sp>
       <p:sp>
         <p:nvSpPr>
-          <p:cNvPr id="4" name="text-113">
+          <p:cNvPr id="4" name="text-117">
             <a:extLst xmlns:a="http://schemas.openxmlformats.org/drawingml/2006/main">
               <a:ext uri="{FF2B5EF4-FFF2-40B4-BE49-F238E27FC236}">
-                <a16:creationId xmlns:a16="http://schemas.microsoft.com/office/drawing/2014/main" id="{3843BC07-F4C9-4A09-8BEA-A09B6B0A7056}"/>
+                <a16:creationId xmlns:a16="http://schemas.microsoft.com/office/drawing/2014/main" id="{844298EB-2826-48DE-97F3-A78BE6A15862}"/>
               </a:ext>
             </a:extLst>
           </p:cNvPr>
@@ -20785,7 +21289,7 @@
           <p:cNvPr id="5" name="">
             <a:extLst xmlns:a="http://schemas.openxmlformats.org/drawingml/2006/main">
               <a:ext uri="{FF2B5EF4-FFF2-40B4-BE49-F238E27FC236}">
-                <a16:creationId xmlns:a16="http://schemas.microsoft.com/office/drawing/2014/main" id="{62A08475-E10E-49BE-A4A3-EFAFA32654CB}"/>
+                <a16:creationId xmlns:a16="http://schemas.microsoft.com/office/drawing/2014/main" id="{57199ACF-7249-47AA-AA0D-320FD98C24A0}"/>
               </a:ext>
             </a:extLst>
           </p:cNvPr>
@@ -21032,7 +21536,7 @@
                           <a:ea typeface="Inter"/>
                           <a:cs typeface="Inter"/>
                         </a:rPr>
-                        <a:t>Complete public workflow, 25 Oct</a:t>
+                        <a:t>Public H5AD workflow, 26 Oct</a:t>
                       </a:r>
                     </a:p>
                   </a:txBody>
@@ -21228,7 +21732,7 @@
                           <a:ea typeface="Inter"/>
                           <a:cs typeface="Inter"/>
                         </a:rPr>
-                        <a:t>Zetaris provenance + H-MEM correction recall</a:t>
+                        <a:t>Zetaris provenance + H-MEM review recall</a:t>
                       </a:r>
                     </a:p>
                   </a:txBody>
@@ -21293,10 +21797,10 @@
       </p:graphicFrame>
       <p:sp>
         <p:nvSpPr>
-          <p:cNvPr id="6" name="text-114">
+          <p:cNvPr id="6" name="text-118">
             <a:extLst xmlns:a="http://schemas.openxmlformats.org/drawingml/2006/main">
               <a:ext uri="{FF2B5EF4-FFF2-40B4-BE49-F238E27FC236}">
-                <a16:creationId xmlns:a16="http://schemas.microsoft.com/office/drawing/2014/main" id="{FD189DEF-0063-45D6-9389-96A254952F82}"/>
+                <a16:creationId xmlns:a16="http://schemas.microsoft.com/office/drawing/2014/main" id="{30013FB6-4D15-4C45-B1DC-FBAD136A7040}"/>
               </a:ext>
             </a:extLst>
           </p:cNvPr>
@@ -21451,10 +21955,10 @@
       </p:sp>
       <p:sp>
         <p:nvSpPr>
-          <p:cNvPr id="7" name="text-115">
+          <p:cNvPr id="7" name="text-119">
             <a:extLst xmlns:a="http://schemas.openxmlformats.org/drawingml/2006/main">
               <a:ext uri="{FF2B5EF4-FFF2-40B4-BE49-F238E27FC236}">
-                <a16:creationId xmlns:a16="http://schemas.microsoft.com/office/drawing/2014/main" id="{94094437-5D5A-4722-8981-80B6809751C2}"/>
+                <a16:creationId xmlns:a16="http://schemas.microsoft.com/office/drawing/2014/main" id="{91AE7586-0B00-4BE6-B09D-03CAB42A1D16}"/>
               </a:ext>
             </a:extLst>
           </p:cNvPr>
@@ -21610,7 +22114,7 @@
     </p:spTree>
     <p:extLst>
       <p:ext uri="{BB962C8B-B14F-4D97-AF65-F5344CB8AC3E}">
-        <p14:creationId xmlns:p14="http://schemas.microsoft.com/office/powerpoint/2010/main" val="670019763"/>
+        <p14:creationId xmlns:p14="http://schemas.microsoft.com/office/powerpoint/2010/main" val="1817681348"/>
       </p:ext>
     </p:extLst>
   </p:cSld>
@@ -21638,10 +22142,10 @@
       </p:grpSpPr>
       <p:sp>
         <p:nvSpPr>
-          <p:cNvPr id="13" name="text-116">
+          <p:cNvPr id="13" name="text-120">
             <a:extLst xmlns:a="http://schemas.openxmlformats.org/drawingml/2006/main">
               <a:ext uri="{FF2B5EF4-FFF2-40B4-BE49-F238E27FC236}">
-                <a16:creationId xmlns:a16="http://schemas.microsoft.com/office/drawing/2014/main" id="{97A7CFD1-8C01-4CBA-A6E8-424E46F5290B}"/>
+                <a16:creationId xmlns:a16="http://schemas.microsoft.com/office/drawing/2014/main" id="{7BF13BC4-9CDF-4875-8D7C-52F68E7213D0}"/>
               </a:ext>
             </a:extLst>
           </p:cNvPr>
@@ -21789,17 +22293,17 @@
                 <a:ea typeface="Inter"/>
                 <a:cs typeface="Inter"/>
               </a:rPr>
-              <a:t>09 / WHAT REMAINS</a:t>
+              <a:t>09 / CURRENT STAGE</a:t>
             </a:r>
           </a:p>
         </p:txBody>
       </p:sp>
       <p:sp>
         <p:nvSpPr>
-          <p:cNvPr id="2" name="text-117">
+          <p:cNvPr id="2" name="text-121">
             <a:extLst xmlns:a="http://schemas.openxmlformats.org/drawingml/2006/main">
               <a:ext uri="{FF2B5EF4-FFF2-40B4-BE49-F238E27FC236}">
-                <a16:creationId xmlns:a16="http://schemas.microsoft.com/office/drawing/2014/main" id="{25CA35B7-B3A2-4A9C-94E8-AC3ECBE8A382}"/>
+                <a16:creationId xmlns:a16="http://schemas.microsoft.com/office/drawing/2014/main" id="{0ECAE63C-99F1-4450-B5DE-ECE22F542543}"/>
               </a:ext>
             </a:extLst>
           </p:cNvPr>
@@ -21947,17 +22451,17 @@
                 <a:ea typeface="Inter"/>
                 <a:cs typeface="Inter"/>
               </a:rPr>
-              <a:t>H5AD upload is the next gap to close.</a:t>
+              <a:t>From uploaded counts to a reviewed cell map.</a:t>
             </a:r>
           </a:p>
         </p:txBody>
       </p:sp>
       <p:sp>
         <p:nvSpPr>
-          <p:cNvPr id="3" name="text-118">
+          <p:cNvPr id="3" name="text-122">
             <a:extLst xmlns:a="http://schemas.openxmlformats.org/drawingml/2006/main">
               <a:ext uri="{FF2B5EF4-FFF2-40B4-BE49-F238E27FC236}">
-                <a16:creationId xmlns:a16="http://schemas.microsoft.com/office/drawing/2014/main" id="{5A54AAE5-D138-4838-918D-3ABD63225CEF}"/>
+                <a16:creationId xmlns:a16="http://schemas.microsoft.com/office/drawing/2014/main" id="{92EEECB9-6EA9-448A-8AC1-660CF7E3B69E}"/>
               </a:ext>
             </a:extLst>
           </p:cNvPr>
@@ -22112,10 +22616,10 @@
       </p:sp>
       <p:sp>
         <p:nvSpPr>
-          <p:cNvPr id="4" name="text-119">
+          <p:cNvPr id="4" name="text-123">
             <a:extLst xmlns:a="http://schemas.openxmlformats.org/drawingml/2006/main">
               <a:ext uri="{FF2B5EF4-FFF2-40B4-BE49-F238E27FC236}">
-                <a16:creationId xmlns:a16="http://schemas.microsoft.com/office/drawing/2014/main" id="{555F3650-4157-4A80-B3D8-E8E60ED2E09E}"/>
+                <a16:creationId xmlns:a16="http://schemas.microsoft.com/office/drawing/2014/main" id="{68BEE5AB-8C26-4E91-9FB0-AF4FC40C7CDC}"/>
               </a:ext>
             </a:extLst>
           </p:cNvPr>
@@ -22270,10 +22774,10 @@
       </p:sp>
       <p:sp>
         <p:nvSpPr>
-          <p:cNvPr id="5" name="box-120">
+          <p:cNvPr id="5" name="box-124">
             <a:extLst xmlns:a="http://schemas.openxmlformats.org/drawingml/2006/main">
               <a:ext uri="{FF2B5EF4-FFF2-40B4-BE49-F238E27FC236}">
-                <a16:creationId xmlns:a16="http://schemas.microsoft.com/office/drawing/2014/main" id="{62F132F7-D45D-462E-A2C2-7D4E208211FA}"/>
+                <a16:creationId xmlns:a16="http://schemas.microsoft.com/office/drawing/2014/main" id="{D73001FE-99C2-45C1-A644-9908F83B0E0C}"/>
               </a:ext>
             </a:extLst>
           </p:cNvPr>
@@ -22300,10 +22804,10 @@
       </p:sp>
       <p:sp>
         <p:nvSpPr>
-          <p:cNvPr id="6" name="text-121">
+          <p:cNvPr id="6" name="text-125">
             <a:extLst xmlns:a="http://schemas.openxmlformats.org/drawingml/2006/main">
               <a:ext uri="{FF2B5EF4-FFF2-40B4-BE49-F238E27FC236}">
-                <a16:creationId xmlns:a16="http://schemas.microsoft.com/office/drawing/2014/main" id="{5886612D-0CA7-4A9C-8F5B-256786E49ED7}"/>
+                <a16:creationId xmlns:a16="http://schemas.microsoft.com/office/drawing/2014/main" id="{8290AF69-1FC7-47D4-AD47-32A10B949B55}"/>
               </a:ext>
             </a:extLst>
           </p:cNvPr>
@@ -22331,7 +22835,7 @@
           </a:bodyPr>
           <a:lstStyle xmlns:a="http://schemas.openxmlformats.org/drawingml/2006/main">
             <a:defPPr>
-              <a:defRPr sz="2400" b="1">
+              <a:defRPr sz="2250" b="1">
                 <a:solidFill>
                   <a:srgbClr val="1B5E20"/>
                 </a:solidFill>
@@ -22341,7 +22845,7 @@
               </a:defRPr>
             </a:defPPr>
             <a:lvl1pPr>
-              <a:defRPr sz="2400" b="1">
+              <a:defRPr sz="2250" b="1">
                 <a:solidFill>
                   <a:srgbClr val="1B5E20"/>
                 </a:solidFill>
@@ -22351,7 +22855,7 @@
               </a:defRPr>
             </a:lvl1pPr>
             <a:lvl2pPr>
-              <a:defRPr sz="2400" b="1">
+              <a:defRPr sz="2250" b="1">
                 <a:solidFill>
                   <a:srgbClr val="1B5E20"/>
                 </a:solidFill>
@@ -22361,7 +22865,7 @@
               </a:defRPr>
             </a:lvl2pPr>
             <a:lvl3pPr>
-              <a:defRPr sz="2400" b="1">
+              <a:defRPr sz="2250" b="1">
                 <a:solidFill>
                   <a:srgbClr val="1B5E20"/>
                 </a:solidFill>
@@ -22371,7 +22875,7 @@
               </a:defRPr>
             </a:lvl3pPr>
             <a:lvl4pPr>
-              <a:defRPr sz="2400" b="1">
+              <a:defRPr sz="2250" b="1">
                 <a:solidFill>
                   <a:srgbClr val="1B5E20"/>
                 </a:solidFill>
@@ -22381,7 +22885,7 @@
               </a:defRPr>
             </a:lvl4pPr>
             <a:lvl5pPr>
-              <a:defRPr sz="2400" b="1">
+              <a:defRPr sz="2250" b="1">
                 <a:solidFill>
                   <a:srgbClr val="1B5E20"/>
                 </a:solidFill>
@@ -22391,7 +22895,7 @@
               </a:defRPr>
             </a:lvl5pPr>
             <a:lvl6pPr>
-              <a:defRPr sz="2400" b="1">
+              <a:defRPr sz="2250" b="1">
                 <a:solidFill>
                   <a:srgbClr val="1B5E20"/>
                 </a:solidFill>
@@ -22401,7 +22905,7 @@
               </a:defRPr>
             </a:lvl6pPr>
             <a:lvl7pPr>
-              <a:defRPr sz="2400" b="1">
+              <a:defRPr sz="2250" b="1">
                 <a:solidFill>
                   <a:srgbClr val="1B5E20"/>
                 </a:solidFill>
@@ -22411,7 +22915,7 @@
               </a:defRPr>
             </a:lvl7pPr>
             <a:lvl8pPr>
-              <a:defRPr sz="2400" b="1">
+              <a:defRPr sz="2250" b="1">
                 <a:solidFill>
                   <a:srgbClr val="1B5E20"/>
                 </a:solidFill>
@@ -22421,7 +22925,7 @@
               </a:defRPr>
             </a:lvl8pPr>
             <a:lvl9pPr>
-              <a:defRPr sz="2400" b="1">
+              <a:defRPr sz="2250" b="1">
                 <a:solidFill>
                   <a:srgbClr val="1B5E20"/>
                 </a:solidFill>
@@ -22433,7 +22937,7 @@
           </a:lstStyle>
           <a:p xmlns:a="http://schemas.openxmlformats.org/drawingml/2006/main">
             <a:pPr>
-              <a:defRPr sz="2400" b="1">
+              <a:defRPr sz="2250" b="1">
                 <a:solidFill>
                   <a:srgbClr val="1B5E20"/>
                 </a:solidFill>
@@ -22443,7 +22947,7 @@
               </a:defRPr>
             </a:pPr>
             <a:r>
-              <a:rPr sz="2400" b="1">
+              <a:rPr sz="2250" b="1">
                 <a:solidFill>
                   <a:srgbClr val="1B5E20"/>
                 </a:solidFill>
@@ -22451,17 +22955,17 @@
                 <a:ea typeface="Inter"/>
                 <a:cs typeface="Inter"/>
               </a:rPr>
-              <a:t>Works today</a:t>
+              <a:t>Working in the public demo</a:t>
             </a:r>
           </a:p>
         </p:txBody>
       </p:sp>
       <p:sp>
         <p:nvSpPr>
-          <p:cNvPr id="7" name="text-122">
+          <p:cNvPr id="7" name="text-126">
             <a:extLst xmlns:a="http://schemas.openxmlformats.org/drawingml/2006/main">
               <a:ext uri="{FF2B5EF4-FFF2-40B4-BE49-F238E27FC236}">
-                <a16:creationId xmlns:a16="http://schemas.microsoft.com/office/drawing/2014/main" id="{0850CAFA-EB8E-46B7-85E2-65B462B52E5D}"/>
+                <a16:creationId xmlns:a16="http://schemas.microsoft.com/office/drawing/2014/main" id="{4BFA7A70-8EC0-4F87-ABC6-D7C9C51F6CB5}"/>
               </a:ext>
             </a:extLst>
           </p:cNvPr>
@@ -22609,7 +23113,7 @@
                 <a:ea typeface="Inter"/>
                 <a:cs typeface="Inter"/>
               </a:rPr>
-              <a:t>Published soybean root demo</a:t>
+              <a:t>H5AD upload and data checks</a:t>
             </a:r>
           </a:p>
           <a:p xmlns:a="http://schemas.openxmlformats.org/drawingml/2006/main">
@@ -22632,7 +23136,7 @@
                 <a:ea typeface="Inter"/>
                 <a:cs typeface="Inter"/>
               </a:rPr>
-              <a:t>Measured annotation and visual cards</a:t>
+              <a:t>Interactive map and annotation</a:t>
             </a:r>
           </a:p>
           <a:p xmlns:a="http://schemas.openxmlformats.org/drawingml/2006/main">
@@ -22655,7 +23159,7 @@
                 <a:ea typeface="Inter"/>
                 <a:cs typeface="Inter"/>
               </a:rPr>
-              <a:t>Marker-list CSV imports</a:t>
+              <a:t>Live Zetaris marker reference</a:t>
             </a:r>
           </a:p>
           <a:p xmlns:a="http://schemas.openxmlformats.org/drawingml/2006/main">
@@ -22678,17 +23182,17 @@
                 <a:ea typeface="Inter"/>
                 <a:cs typeface="Inter"/>
               </a:rPr>
-              <a:t>Zetaris reference and H-MEM reviews</a:t>
+              <a:t>Meterless H-MEM review recall</a:t>
             </a:r>
           </a:p>
         </p:txBody>
       </p:sp>
       <p:sp>
         <p:nvSpPr>
-          <p:cNvPr id="8" name="box-123">
+          <p:cNvPr id="8" name="box-127">
             <a:extLst xmlns:a="http://schemas.openxmlformats.org/drawingml/2006/main">
               <a:ext uri="{FF2B5EF4-FFF2-40B4-BE49-F238E27FC236}">
-                <a16:creationId xmlns:a16="http://schemas.microsoft.com/office/drawing/2014/main" id="{15430080-B98F-4328-93D9-178F3C268DB0}"/>
+                <a16:creationId xmlns:a16="http://schemas.microsoft.com/office/drawing/2014/main" id="{E1E1C1B1-130E-4B91-A7FC-C4CDEBF851F6}"/>
               </a:ext>
             </a:extLst>
           </p:cNvPr>
@@ -22715,10 +23219,10 @@
       </p:sp>
       <p:sp>
         <p:nvSpPr>
-          <p:cNvPr id="9" name="text-124">
+          <p:cNvPr id="9" name="text-128">
             <a:extLst xmlns:a="http://schemas.openxmlformats.org/drawingml/2006/main">
               <a:ext uri="{FF2B5EF4-FFF2-40B4-BE49-F238E27FC236}">
-                <a16:creationId xmlns:a16="http://schemas.microsoft.com/office/drawing/2014/main" id="{A58D0308-645B-4C4A-BFDE-DAD6774879E6}"/>
+                <a16:creationId xmlns:a16="http://schemas.microsoft.com/office/drawing/2014/main" id="{E45AE100-40A8-450F-B6A1-0BF316319B39}"/>
               </a:ext>
             </a:extLst>
           </p:cNvPr>
@@ -22866,17 +23370,17 @@
                 <a:ea typeface="Inter"/>
                 <a:cs typeface="Inter"/>
               </a:rPr>
-              <a:t>Implementation in progress</a:t>
+              <a:t>Next scientific work</a:t>
             </a:r>
           </a:p>
         </p:txBody>
       </p:sp>
       <p:sp>
         <p:nvSpPr>
-          <p:cNvPr id="10" name="text-125">
+          <p:cNvPr id="10" name="text-129">
             <a:extLst xmlns:a="http://schemas.openxmlformats.org/drawingml/2006/main">
               <a:ext uri="{FF2B5EF4-FFF2-40B4-BE49-F238E27FC236}">
-                <a16:creationId xmlns:a16="http://schemas.microsoft.com/office/drawing/2014/main" id="{D19CA64E-B5AA-45D9-A914-0BD89A5058F8}"/>
+                <a16:creationId xmlns:a16="http://schemas.microsoft.com/office/drawing/2014/main" id="{9276556E-EF49-4C15-A539-A513D3CCCB1C}"/>
               </a:ext>
             </a:extLst>
           </p:cNvPr>
@@ -23024,7 +23528,7 @@
                 <a:ea typeface="Inter"/>
                 <a:cs typeface="Inter"/>
               </a:rPr>
-              <a:t>Resumable H5AD uploads</a:t>
+              <a:t>Independent biological validation</a:t>
             </a:r>
           </a:p>
           <a:p xmlns:a="http://schemas.openxmlformats.org/drawingml/2006/main">
@@ -23047,7 +23551,7 @@
                 <a:ea typeface="Inter"/>
                 <a:cs typeface="Inter"/>
               </a:rPr>
-              <a:t>Counts, group and genome validation</a:t>
+              <a:t>Broader marker coverage</a:t>
             </a:r>
           </a:p>
           <a:p xmlns:a="http://schemas.openxmlformats.org/drawingml/2006/main">
@@ -23070,7 +23574,7 @@
                 <a:ea typeface="Inter"/>
                 <a:cs typeface="Inter"/>
               </a:rPr>
-              <a:t>Private dataset attachment</a:t>
+              <a:t>Gene-build and ortholog mapping</a:t>
             </a:r>
           </a:p>
           <a:p xmlns:a="http://schemas.openxmlformats.org/drawingml/2006/main">
@@ -23093,17 +23597,17 @@
                 <a:ea typeface="Inter"/>
                 <a:cs typeface="Inter"/>
               </a:rPr>
-              <a:t>A complete uploaded-file demo</a:t>
+              <a:t>Other tissues and plants</a:t>
             </a:r>
           </a:p>
         </p:txBody>
       </p:sp>
       <p:sp>
         <p:nvSpPr>
-          <p:cNvPr id="11" name="text-126">
+          <p:cNvPr id="11" name="text-130">
             <a:extLst xmlns:a="http://schemas.openxmlformats.org/drawingml/2006/main">
               <a:ext uri="{FF2B5EF4-FFF2-40B4-BE49-F238E27FC236}">
-                <a16:creationId xmlns:a16="http://schemas.microsoft.com/office/drawing/2014/main" id="{8687F050-4538-446D-A545-2FE39249B41F}"/>
+                <a16:creationId xmlns:a16="http://schemas.microsoft.com/office/drawing/2014/main" id="{F4E593BD-B3D7-460A-91F0-455CC1CD2295}"/>
               </a:ext>
             </a:extLst>
           </p:cNvPr>
@@ -23251,17 +23755,17 @@
                 <a:ea typeface="Inter"/>
                 <a:cs typeface="Inter"/>
               </a:rPr>
-              <a:t>Also open: independent biological validation and intermittent local CLI failures.</a:t>
+              <a:t>One actual uploaded dataset, one agent conversation, both required sponsors.</a:t>
             </a:r>
           </a:p>
         </p:txBody>
       </p:sp>
       <p:sp>
         <p:nvSpPr>
-          <p:cNvPr id="12" name="text-127">
+          <p:cNvPr id="12" name="text-131">
             <a:extLst xmlns:a="http://schemas.openxmlformats.org/drawingml/2006/main">
               <a:ext uri="{FF2B5EF4-FFF2-40B4-BE49-F238E27FC236}">
-                <a16:creationId xmlns:a16="http://schemas.microsoft.com/office/drawing/2014/main" id="{5886A0CF-F7F4-409C-AC67-2AC934FC9DE7}"/>
+                <a16:creationId xmlns:a16="http://schemas.microsoft.com/office/drawing/2014/main" id="{9079931B-CBC7-4985-98EC-D369D4F7D1C3}"/>
               </a:ext>
             </a:extLst>
           </p:cNvPr>
@@ -23409,7 +23913,7 @@
                 <a:ea typeface="Inter"/>
                 <a:cs typeface="Inter"/>
               </a:rPr>
-              <a:t>Demo source: verified GSE270392 counts converted to H5AD, preserving groups and UMAP.</a:t>
+              <a:t>Demo input: 7,496 soybean root nuclei. Original counts, groups and UMAP preserved.</a:t>
             </a:r>
           </a:p>
         </p:txBody>
@@ -23417,7 +23921,7 @@
     </p:spTree>
     <p:extLst>
       <p:ext uri="{BB962C8B-B14F-4D97-AF65-F5344CB8AC3E}">
-        <p14:creationId xmlns:p14="http://schemas.microsoft.com/office/powerpoint/2010/main" val="599450791"/>
+        <p14:creationId xmlns:p14="http://schemas.microsoft.com/office/powerpoint/2010/main" val="1170625893"/>
       </p:ext>
     </p:extLst>
   </p:cSld>

</xml_diff>